<commit_message>
Sync storyboard team slide with current roster
</commit_message>
<xml_diff>
--- a/slides/GATE-3/AEGIS_Gate3_Storyboard.pptx
+++ b/slides/GATE-3/AEGIS_Gate3_Storyboard.pptx
@@ -27849,28 +27849,6 @@
                 <a:latin typeface="Calibri"/>
               </a:rPr>
               <a:t>Fauzan Ejaz (Captain)</a:t>
-            </a:r>
-          </a:p>
-          <a:p>
-            <a:r>
-              <a:rPr sz="2000">
-                <a:solidFill>
-                  <a:srgbClr val="020C31"/>
-                </a:solidFill>
-                <a:latin typeface="Calibri"/>
-              </a:rPr>
-              <a:t>Adithya Zacharia Valavi</a:t>
-            </a:r>
-          </a:p>
-          <a:p>
-            <a:r>
-              <a:rPr sz="2000">
-                <a:solidFill>
-                  <a:srgbClr val="020C31"/>
-                </a:solidFill>
-                <a:latin typeface="Calibri"/>
-              </a:rPr>
-              <a:t>Ghazanfar Anees Siddiqui</a:t>
             </a:r>
           </a:p>
           <a:p>

</xml_diff>

<commit_message>
Add "slides to be used" field to the storyboard, per the actual requirement
The requirement document asks for scenes, script, AND which slides/assets
to use - the first version only had the first two. Each of the 48 shots
now names either a specific existing asset (a Gate 2 deck slide, the
architecture diagram, the live demo video, a Gate 3 report file) or is
explicitly marked as new footage/graphic needed, so nothing is left
ambiguous for the videomaker briefing.
</commit_message>
<xml_diff>
--- a/slides/GATE-3/AEGIS_Gate3_Storyboard.pptx
+++ b/slides/GATE-3/AEGIS_Gate3_Storyboard.pptx
@@ -6002,7 +6002,7 @@
           <a:p>
             <a:pPr algn="l"/>
             <a:r>
-              <a:rPr sz="900" b="1">
+              <a:rPr sz="850" b="1">
                 <a:solidFill>
                   <a:srgbClr val="020C31"/>
                 </a:solidFill>
@@ -6014,13 +6014,25 @@
           <a:p>
             <a:pPr algn="l"/>
             <a:r>
-              <a:rPr sz="850" i="1">
+              <a:rPr sz="800" i="1">
                 <a:solidFill>
                   <a:srgbClr val="555555"/>
                 </a:solidFill>
                 <a:latin typeface="Calibri"/>
               </a:rPr>
               <a:t>"A stolen ID badge still opens the door."</a:t>
+            </a:r>
+          </a:p>
+          <a:p>
+            <a:pPr algn="l"/>
+            <a:r>
+              <a:rPr sz="750" b="1">
+                <a:solidFill>
+                  <a:srgbClr val="0E7090"/>
+                </a:solidFill>
+                <a:latin typeface="Calibri"/>
+              </a:rPr>
+              <a:t>NEW: live-action B-roll (badge scan)</a:t>
             </a:r>
           </a:p>
         </p:txBody>
@@ -6049,7 +6061,7 @@
           <a:p>
             <a:pPr algn="l"/>
             <a:r>
-              <a:rPr sz="900" b="1">
+              <a:rPr sz="850" b="1">
                 <a:solidFill>
                   <a:srgbClr val="020C31"/>
                 </a:solidFill>
@@ -6061,13 +6073,25 @@
           <a:p>
             <a:pPr algn="l"/>
             <a:r>
-              <a:rPr sz="850" i="1">
+              <a:rPr sz="800" i="1">
                 <a:solidFill>
                   <a:srgbClr val="555555"/>
                 </a:solidFill>
                 <a:latin typeface="Calibri"/>
               </a:rPr>
               <a:t>"The badge is valid."</a:t>
+            </a:r>
+          </a:p>
+          <a:p>
+            <a:pPr algn="l"/>
+            <a:r>
+              <a:rPr sz="750" b="1">
+                <a:solidFill>
+                  <a:srgbClr val="0E7090"/>
+                </a:solidFill>
+                <a:latin typeface="Calibri"/>
+              </a:rPr>
+              <a:t>NEW: live-action B-roll (same shot, continued)</a:t>
             </a:r>
           </a:p>
         </p:txBody>
@@ -6096,7 +6120,7 @@
           <a:p>
             <a:pPr algn="l"/>
             <a:r>
-              <a:rPr sz="900" b="1">
+              <a:rPr sz="850" b="1">
                 <a:solidFill>
                   <a:srgbClr val="020C31"/>
                 </a:solidFill>
@@ -6108,13 +6132,25 @@
           <a:p>
             <a:pPr algn="l"/>
             <a:r>
-              <a:rPr sz="850" i="1">
+              <a:rPr sz="800" i="1">
                 <a:solidFill>
                   <a:srgbClr val="555555"/>
                 </a:solidFill>
                 <a:latin typeface="Calibri"/>
               </a:rPr>
               <a:t>"But is the person behind it really who they claim to be?"</a:t>
+            </a:r>
+          </a:p>
+          <a:p>
+            <a:pPr algn="l"/>
+            <a:r>
+              <a:rPr sz="750" b="1">
+                <a:solidFill>
+                  <a:srgbClr val="0E7090"/>
+                </a:solidFill>
+                <a:latin typeface="Calibri"/>
+              </a:rPr>
+              <a:t>ASSET: assets/architecture.png</a:t>
             </a:r>
           </a:p>
         </p:txBody>
@@ -6143,7 +6179,7 @@
           <a:p>
             <a:pPr algn="l"/>
             <a:r>
-              <a:rPr sz="900" b="1">
+              <a:rPr sz="850" b="1">
                 <a:solidFill>
                   <a:srgbClr val="020C31"/>
                 </a:solidFill>
@@ -6155,13 +6191,25 @@
           <a:p>
             <a:pPr algn="l"/>
             <a:r>
-              <a:rPr sz="850" i="1">
+              <a:rPr sz="800" i="1">
                 <a:solidFill>
                   <a:srgbClr val="555555"/>
                 </a:solidFill>
                 <a:latin typeface="Calibri"/>
               </a:rPr>
               <a:t>AI agents and automations now call the network directly.</a:t>
+            </a:r>
+          </a:p>
+          <a:p>
+            <a:pPr algn="l"/>
+            <a:r>
+              <a:rPr sz="750" b="1">
+                <a:solidFill>
+                  <a:srgbClr val="0E7090"/>
+                </a:solidFill>
+                <a:latin typeface="Calibri"/>
+              </a:rPr>
+              <a:t>ASSET: reports/GATE-2/aegis_hook_analogy.png (right panel, "THE NETWORK")</a:t>
             </a:r>
           </a:p>
         </p:txBody>
@@ -6190,7 +6238,7 @@
           <a:p>
             <a:pPr algn="l"/>
             <a:r>
-              <a:rPr sz="900" b="1">
+              <a:rPr sz="850" b="1">
                 <a:solidFill>
                   <a:srgbClr val="020C31"/>
                 </a:solidFill>
@@ -6202,13 +6250,25 @@
           <a:p>
             <a:pPr algn="l"/>
             <a:r>
-              <a:rPr sz="850" i="1">
+              <a:rPr sz="800" i="1">
                 <a:solidFill>
                   <a:srgbClr val="555555"/>
                 </a:solidFill>
                 <a:latin typeface="Calibri"/>
               </a:rPr>
               <a:t>A stolen or misused credential still passes every check.</a:t>
+            </a:r>
+          </a:p>
+          <a:p>
+            <a:pPr algn="l"/>
+            <a:r>
+              <a:rPr sz="750" b="1">
+                <a:solidFill>
+                  <a:srgbClr val="0E7090"/>
+                </a:solidFill>
+                <a:latin typeface="Calibri"/>
+              </a:rPr>
+              <a:t>ASSET: reports/GATE-2/aegis_hook_analogy.png (checkmark line)</a:t>
             </a:r>
           </a:p>
         </p:txBody>
@@ -6237,25 +6297,37 @@
           <a:p>
             <a:pPr algn="l"/>
             <a:r>
-              <a:rPr sz="900" b="1">
+              <a:rPr sz="850" b="1">
                 <a:solidFill>
                   <a:srgbClr val="020C31"/>
                 </a:solidFill>
                 <a:latin typeface="Calibri"/>
               </a:rPr>
-              <a:t>Cut to red alert icon / question mark</a:t>
+              <a:t>Cut to red alert icon / question mark, AEGIS title reveal</a:t>
             </a:r>
           </a:p>
           <a:p>
             <a:pPr algn="l"/>
             <a:r>
-              <a:rPr sz="850" i="1">
+              <a:rPr sz="800" i="1">
                 <a:solidFill>
                   <a:srgbClr val="555555"/>
                 </a:solidFill>
                 <a:latin typeface="Calibri"/>
               </a:rPr>
               <a:t>"AEGIS" title card reveal.</a:t>
+            </a:r>
+          </a:p>
+          <a:p>
+            <a:pPr algn="l"/>
+            <a:r>
+              <a:rPr sz="750" b="1">
+                <a:solidFill>
+                  <a:srgbClr val="0E7090"/>
+                </a:solidFill>
+                <a:latin typeface="Calibri"/>
+              </a:rPr>
+              <a:t>ASSET: slides/GATE-2/AEGIS_Gate2_Official.pptx, Slide 3 (hook slide)</a:t>
             </a:r>
           </a:p>
         </p:txBody>
@@ -8993,7 +9065,7 @@
           <a:p>
             <a:pPr algn="l"/>
             <a:r>
-              <a:rPr sz="900" b="1">
+              <a:rPr sz="850" b="1">
                 <a:solidFill>
                   <a:srgbClr val="020C31"/>
                 </a:solidFill>
@@ -9005,13 +9077,25 @@
           <a:p>
             <a:pPr algn="l"/>
             <a:r>
-              <a:rPr sz="850" i="1">
+              <a:rPr sz="800" i="1">
                 <a:solidFill>
                   <a:srgbClr val="555555"/>
                 </a:solidFill>
                 <a:latin typeface="Calibri"/>
               </a:rPr>
               <a:t>"This is AEGIS."</a:t>
+            </a:r>
+          </a:p>
+          <a:p>
+            <a:pPr algn="l"/>
+            <a:r>
+              <a:rPr sz="750" b="1">
+                <a:solidFill>
+                  <a:srgbClr val="0E7090"/>
+                </a:solidFill>
+                <a:latin typeface="Calibri"/>
+              </a:rPr>
+              <a:t>ASSET: slides/GATE-2/AEGIS_Gate2_Official.pptx, Slide 1 (cover)</a:t>
             </a:r>
           </a:p>
         </p:txBody>
@@ -9040,7 +9124,7 @@
           <a:p>
             <a:pPr algn="l"/>
             <a:r>
-              <a:rPr sz="900" b="1">
+              <a:rPr sz="850" b="1">
                 <a:solidFill>
                   <a:srgbClr val="020C31"/>
                 </a:solidFill>
@@ -9052,13 +9136,25 @@
           <a:p>
             <a:pPr algn="l"/>
             <a:r>
-              <a:rPr sz="850" i="1">
+              <a:rPr sz="800" i="1">
                 <a:solidFill>
                   <a:srgbClr val="555555"/>
                 </a:solidFill>
                 <a:latin typeface="Calibri"/>
               </a:rPr>
               <a:t>A zero-trust identity gate for AI agents on the network.</a:t>
+            </a:r>
+          </a:p>
+          <a:p>
+            <a:pPr algn="l"/>
+            <a:r>
+              <a:rPr sz="750" b="1">
+                <a:solidFill>
+                  <a:srgbClr val="0E7090"/>
+                </a:solidFill>
+                <a:latin typeface="Calibri"/>
+              </a:rPr>
+              <a:t>ASSET: assets/architecture.png (cropped/teased)</a:t>
             </a:r>
           </a:p>
         </p:txBody>
@@ -9087,7 +9183,7 @@
           <a:p>
             <a:pPr algn="l"/>
             <a:r>
-              <a:rPr sz="900" b="1">
+              <a:rPr sz="850" b="1">
                 <a:solidFill>
                   <a:srgbClr val="020C31"/>
                 </a:solidFill>
@@ -9099,13 +9195,25 @@
           <a:p>
             <a:pPr algn="l"/>
             <a:r>
-              <a:rPr sz="850" i="1">
+              <a:rPr sz="800" i="1">
                 <a:solidFill>
                   <a:srgbClr val="555555"/>
                 </a:solidFill>
                 <a:latin typeface="Calibri"/>
               </a:rPr>
               <a:t>Built by Team 4, 5G Academy 2026.</a:t>
+            </a:r>
+          </a:p>
+          <a:p>
+            <a:pPr algn="l"/>
+            <a:r>
+              <a:rPr sz="750" b="1">
+                <a:solidFill>
+                  <a:srgbClr val="0E7090"/>
+                </a:solidFill>
+                <a:latin typeface="Calibri"/>
+              </a:rPr>
+              <a:t>NEW: live-action B-roll (team working)</a:t>
             </a:r>
           </a:p>
         </p:txBody>
@@ -9134,7 +9242,7 @@
           <a:p>
             <a:pPr algn="l"/>
             <a:r>
-              <a:rPr sz="900" b="1">
+              <a:rPr sz="850" b="1">
                 <a:solidFill>
                   <a:srgbClr val="020C31"/>
                 </a:solidFill>
@@ -9146,13 +9254,25 @@
           <a:p>
             <a:pPr algn="l"/>
             <a:r>
-              <a:rPr sz="850" i="1">
+              <a:rPr sz="800" i="1">
                 <a:solidFill>
                   <a:srgbClr val="555555"/>
                 </a:solidFill>
                 <a:latin typeface="Calibri"/>
               </a:rPr>
               <a:t>In partnership with Fastweb and Vodafone.</a:t>
+            </a:r>
+          </a:p>
+          <a:p>
+            <a:pPr algn="l"/>
+            <a:r>
+              <a:rPr sz="750" b="1">
+                <a:solidFill>
+                  <a:srgbClr val="0E7090"/>
+                </a:solidFill>
+                <a:latin typeface="Calibri"/>
+              </a:rPr>
+              <a:t>ASSET: slides/GATE-2/AEGIS_Gate2_Official.pptx, Slide 1 (branding)</a:t>
             </a:r>
           </a:p>
         </p:txBody>
@@ -9181,7 +9301,7 @@
           <a:p>
             <a:pPr algn="l"/>
             <a:r>
-              <a:rPr sz="900" b="1">
+              <a:rPr sz="850" b="1">
                 <a:solidFill>
                   <a:srgbClr val="020C31"/>
                 </a:solidFill>
@@ -9193,13 +9313,25 @@
           <a:p>
             <a:pPr algn="l"/>
             <a:r>
-              <a:rPr sz="850" i="1">
+              <a:rPr sz="800" i="1">
                 <a:solidFill>
                   <a:srgbClr val="555555"/>
                 </a:solidFill>
                 <a:latin typeface="Calibri"/>
               </a:rPr>
               <a:t>Bridge into the problem.</a:t>
+            </a:r>
+          </a:p>
+          <a:p>
+            <a:pPr algn="l"/>
+            <a:r>
+              <a:rPr sz="750" b="1">
+                <a:solidFill>
+                  <a:srgbClr val="0E7090"/>
+                </a:solidFill>
+                <a:latin typeface="Calibri"/>
+              </a:rPr>
+              <a:t>NEW: transition graphic</a:t>
             </a:r>
           </a:p>
         </p:txBody>
@@ -9228,13 +9360,25 @@
           <a:p>
             <a:pPr algn="l"/>
             <a:r>
-              <a:rPr sz="900" b="1">
+              <a:rPr sz="850" b="1">
                 <a:solidFill>
                   <a:srgbClr val="020C31"/>
                 </a:solidFill>
                 <a:latin typeface="Calibri"/>
               </a:rPr>
               <a:t>Fade to black / section break</a:t>
+            </a:r>
+          </a:p>
+          <a:p>
+            <a:pPr algn="l"/>
+            <a:r>
+              <a:rPr sz="750" b="1">
+                <a:solidFill>
+                  <a:srgbClr val="0E7090"/>
+                </a:solidFill>
+                <a:latin typeface="Calibri"/>
+              </a:rPr>
+              <a:t>N/A - transition only</a:t>
             </a:r>
           </a:p>
         </p:txBody>
@@ -12001,7 +12145,7 @@
           <a:p>
             <a:pPr algn="l"/>
             <a:r>
-              <a:rPr sz="900" b="1">
+              <a:rPr sz="850" b="1">
                 <a:solidFill>
                   <a:srgbClr val="020C31"/>
                 </a:solidFill>
@@ -12013,13 +12157,25 @@
           <a:p>
             <a:pPr algn="l"/>
             <a:r>
-              <a:rPr sz="850" i="1">
+              <a:rPr sz="800" i="1">
                 <a:solidFill>
                   <a:srgbClr val="555555"/>
                 </a:solidFill>
                 <a:latin typeface="Calibri"/>
               </a:rPr>
               <a:t>Orchestration and automation tools now call 5G Network Functions directly.</a:t>
+            </a:r>
+          </a:p>
+          <a:p>
+            <a:pPr algn="l"/>
+            <a:r>
+              <a:rPr sz="750" b="1">
+                <a:solidFill>
+                  <a:srgbClr val="0E7090"/>
+                </a:solidFill>
+                <a:latin typeface="Calibri"/>
+              </a:rPr>
+              <a:t>ASSET: slides/GATE-2/AEGIS_Gate2_Official.pptx, Slide 4 (pipeline cards)</a:t>
             </a:r>
           </a:p>
         </p:txBody>
@@ -12048,7 +12204,7 @@
           <a:p>
             <a:pPr algn="l"/>
             <a:r>
-              <a:rPr sz="900" b="1">
+              <a:rPr sz="850" b="1">
                 <a:solidFill>
                   <a:srgbClr val="020C31"/>
                 </a:solidFill>
@@ -12060,13 +12216,25 @@
           <a:p>
             <a:pPr algn="l"/>
             <a:r>
-              <a:rPr sz="850" i="1">
+              <a:rPr sz="800" i="1">
                 <a:solidFill>
                   <a:srgbClr val="555555"/>
                 </a:solidFill>
                 <a:latin typeface="Calibri"/>
               </a:rPr>
               <a:t>Authentication proves you have the right key.</a:t>
+            </a:r>
+          </a:p>
+          <a:p>
+            <a:pPr algn="l"/>
+            <a:r>
+              <a:rPr sz="750" b="1">
+                <a:solidFill>
+                  <a:srgbClr val="0E7090"/>
+                </a:solidFill>
+                <a:latin typeface="Calibri"/>
+              </a:rPr>
+              <a:t>ASSET: reports/GATE-2/aegis_hook_analogy.png (full graphic)</a:t>
             </a:r>
           </a:p>
         </p:txBody>
@@ -12095,7 +12263,7 @@
           <a:p>
             <a:pPr algn="l"/>
             <a:r>
-              <a:rPr sz="900" b="1">
+              <a:rPr sz="850" b="1">
                 <a:solidFill>
                   <a:srgbClr val="020C31"/>
                 </a:solidFill>
@@ -12107,13 +12275,25 @@
           <a:p>
             <a:pPr algn="l"/>
             <a:r>
-              <a:rPr sz="850" i="1">
+              <a:rPr sz="800" i="1">
                 <a:solidFill>
                   <a:srgbClr val="555555"/>
                 </a:solidFill>
                 <a:latin typeface="Calibri"/>
               </a:rPr>
               <a:t>It never asks whether you're still behaving like yourself.</a:t>
+            </a:r>
+          </a:p>
+          <a:p>
+            <a:pPr algn="l"/>
+            <a:r>
+              <a:rPr sz="750" b="1">
+                <a:solidFill>
+                  <a:srgbClr val="0E7090"/>
+                </a:solidFill>
+                <a:latin typeface="Calibri"/>
+              </a:rPr>
+              <a:t>ASSET: slides/GATE-2/AEGIS_Gate2_Official.pptx, Slide 6 ("THE GAP" panel text)</a:t>
             </a:r>
           </a:p>
         </p:txBody>
@@ -12142,7 +12322,7 @@
           <a:p>
             <a:pPr algn="l"/>
             <a:r>
-              <a:rPr sz="900" b="1">
+              <a:rPr sz="850" b="1">
                 <a:solidFill>
                   <a:srgbClr val="020C31"/>
                 </a:solidFill>
@@ -12154,13 +12334,25 @@
           <a:p>
             <a:pPr algn="l"/>
             <a:r>
-              <a:rPr sz="850" i="1">
+              <a:rPr sz="800" i="1">
                 <a:solidFill>
                   <a:srgbClr val="555555"/>
                 </a:solidFill>
                 <a:latin typeface="Calibri"/>
               </a:rPr>
               <a:t>A compromised or stolen credential can sit undetected for weeks.</a:t>
+            </a:r>
+          </a:p>
+          <a:p>
+            <a:pPr algn="l"/>
+            <a:r>
+              <a:rPr sz="750" b="1">
+                <a:solidFill>
+                  <a:srgbClr val="0E7090"/>
+                </a:solidFill>
+                <a:latin typeface="Calibri"/>
+              </a:rPr>
+              <a:t>NEW: live-action B-roll (operator at screen)</a:t>
             </a:r>
           </a:p>
         </p:txBody>
@@ -12189,7 +12381,7 @@
           <a:p>
             <a:pPr algn="l"/>
             <a:r>
-              <a:rPr sz="900" b="1">
+              <a:rPr sz="850" b="1">
                 <a:solidFill>
                   <a:srgbClr val="020C31"/>
                 </a:solidFill>
@@ -12201,13 +12393,25 @@
           <a:p>
             <a:pPr algn="l"/>
             <a:r>
-              <a:rPr sz="850" i="1">
+              <a:rPr sz="800" i="1">
                 <a:solidFill>
                   <a:srgbClr val="555555"/>
                 </a:solidFill>
                 <a:latin typeface="Calibri"/>
               </a:rPr>
               <a:t>The business cost of a one-time-only identity check.</a:t>
+            </a:r>
+          </a:p>
+          <a:p>
+            <a:pPr algn="l"/>
+            <a:r>
+              <a:rPr sz="750" b="1">
+                <a:solidFill>
+                  <a:srgbClr val="0E7090"/>
+                </a:solidFill>
+                <a:latin typeface="Calibri"/>
+              </a:rPr>
+              <a:t>NEW: graphic - pull from Gate 1 deck's economic/business analysis if available</a:t>
             </a:r>
           </a:p>
         </p:txBody>
@@ -12236,7 +12440,7 @@
           <a:p>
             <a:pPr algn="l"/>
             <a:r>
-              <a:rPr sz="900" b="1">
+              <a:rPr sz="850" b="1">
                 <a:solidFill>
                   <a:srgbClr val="020C31"/>
                 </a:solidFill>
@@ -12248,13 +12452,25 @@
           <a:p>
             <a:pPr algn="l"/>
             <a:r>
-              <a:rPr sz="850" i="1">
+              <a:rPr sz="800" i="1">
                 <a:solidFill>
                   <a:srgbClr val="555555"/>
                 </a:solidFill>
                 <a:latin typeface="Calibri"/>
               </a:rPr>
               <a:t>"There's a better way."</a:t>
+            </a:r>
+          </a:p>
+          <a:p>
+            <a:pPr algn="l"/>
+            <a:r>
+              <a:rPr sz="750" b="1">
+                <a:solidFill>
+                  <a:srgbClr val="0E7090"/>
+                </a:solidFill>
+                <a:latin typeface="Calibri"/>
+              </a:rPr>
+              <a:t>NEW: transition graphic</a:t>
             </a:r>
           </a:p>
         </p:txBody>
@@ -15026,7 +15242,7 @@
           <a:p>
             <a:pPr algn="l"/>
             <a:r>
-              <a:rPr sz="900" b="1">
+              <a:rPr sz="850" b="1">
                 <a:solidFill>
                   <a:srgbClr val="020C31"/>
                 </a:solidFill>
@@ -15038,13 +15254,25 @@
           <a:p>
             <a:pPr algn="l"/>
             <a:r>
-              <a:rPr sz="850" i="1">
+              <a:rPr sz="800" i="1">
                 <a:solidFill>
                   <a:srgbClr val="555555"/>
                 </a:solidFill>
                 <a:latin typeface="Calibri"/>
               </a:rPr>
               <a:t>AEGIS builds a behavioural fingerprint for every agent.</a:t>
+            </a:r>
+          </a:p>
+          <a:p>
+            <a:pPr algn="l"/>
+            <a:r>
+              <a:rPr sz="750" b="1">
+                <a:solidFill>
+                  <a:srgbClr val="0E7090"/>
+                </a:solidFill>
+                <a:latin typeface="Calibri"/>
+              </a:rPr>
+              <a:t>ASSET: assets/architecture.png</a:t>
             </a:r>
           </a:p>
         </p:txBody>
@@ -15073,7 +15301,7 @@
           <a:p>
             <a:pPr algn="l"/>
             <a:r>
-              <a:rPr sz="900" b="1">
+              <a:rPr sz="850" b="1">
                 <a:solidFill>
                   <a:srgbClr val="020C31"/>
                 </a:solidFill>
@@ -15085,13 +15313,25 @@
           <a:p>
             <a:pPr algn="l"/>
             <a:r>
-              <a:rPr sz="850" i="1">
+              <a:rPr sz="800" i="1">
                 <a:solidFill>
                   <a:srgbClr val="555555"/>
                 </a:solidFill>
                 <a:latin typeface="Calibri"/>
               </a:rPr>
               <a:t>OBSERVE - every request is captured: who, what, when, how.</a:t>
+            </a:r>
+          </a:p>
+          <a:p>
+            <a:pPr algn="l"/>
+            <a:r>
+              <a:rPr sz="750" b="1">
+                <a:solidFill>
+                  <a:srgbClr val="0E7090"/>
+                </a:solidFill>
+                <a:latin typeface="Calibri"/>
+              </a:rPr>
+              <a:t>ASSET: slides/GATE-2/AEGIS_Gate2_Official.pptx, Slide 4 (OBSERVE card)</a:t>
             </a:r>
           </a:p>
         </p:txBody>
@@ -15120,7 +15360,7 @@
           <a:p>
             <a:pPr algn="l"/>
             <a:r>
-              <a:rPr sz="900" b="1">
+              <a:rPr sz="850" b="1">
                 <a:solidFill>
                   <a:srgbClr val="020C31"/>
                 </a:solidFill>
@@ -15132,13 +15372,25 @@
           <a:p>
             <a:pPr algn="l"/>
             <a:r>
-              <a:rPr sz="850" i="1">
+              <a:rPr sz="800" i="1">
                 <a:solidFill>
                   <a:srgbClr val="555555"/>
                 </a:solidFill>
                 <a:latin typeface="Calibri"/>
               </a:rPr>
               <a:t>FINGERPRINT - that stream becomes a behavioural profile.</a:t>
+            </a:r>
+          </a:p>
+          <a:p>
+            <a:pPr algn="l"/>
+            <a:r>
+              <a:rPr sz="750" b="1">
+                <a:solidFill>
+                  <a:srgbClr val="0E7090"/>
+                </a:solidFill>
+                <a:latin typeface="Calibri"/>
+              </a:rPr>
+              <a:t>ASSET: slides/GATE-2/AEGIS_Gate2_Official.pptx, Slide 4 (FINGERPRINT card)</a:t>
             </a:r>
           </a:p>
         </p:txBody>
@@ -15167,7 +15419,7 @@
           <a:p>
             <a:pPr algn="l"/>
             <a:r>
-              <a:rPr sz="900" b="1">
+              <a:rPr sz="850" b="1">
                 <a:solidFill>
                   <a:srgbClr val="020C31"/>
                 </a:solidFill>
@@ -15179,13 +15431,25 @@
           <a:p>
             <a:pPr algn="l"/>
             <a:r>
-              <a:rPr sz="850" i="1">
+              <a:rPr sz="800" i="1">
                 <a:solidFill>
                   <a:srgbClr val="555555"/>
                 </a:solidFill>
                 <a:latin typeface="Calibri"/>
               </a:rPr>
               <a:t>SCORE - live behaviour is compared to that profile, in real time.</a:t>
+            </a:r>
+          </a:p>
+          <a:p>
+            <a:pPr algn="l"/>
+            <a:r>
+              <a:rPr sz="750" b="1">
+                <a:solidFill>
+                  <a:srgbClr val="0E7090"/>
+                </a:solidFill>
+                <a:latin typeface="Calibri"/>
+              </a:rPr>
+              <a:t>ASSET: slides/GATE-2/AEGIS_Gate2_Official.pptx, Slide 8 (Scoring: Rules+ML Fused)</a:t>
             </a:r>
           </a:p>
         </p:txBody>
@@ -15214,7 +15478,7 @@
           <a:p>
             <a:pPr algn="l"/>
             <a:r>
-              <a:rPr sz="900" b="1">
+              <a:rPr sz="850" b="1">
                 <a:solidFill>
                   <a:srgbClr val="020C31"/>
                 </a:solidFill>
@@ -15226,13 +15490,25 @@
           <a:p>
             <a:pPr algn="l"/>
             <a:r>
-              <a:rPr sz="850" i="1">
+              <a:rPr sz="800" i="1">
                 <a:solidFill>
                   <a:srgbClr val="555555"/>
                 </a:solidFill>
                 <a:latin typeface="Calibri"/>
               </a:rPr>
               <a:t>DECIDE - pass it, challenge it, or shut it down, instantly.</a:t>
+            </a:r>
+          </a:p>
+          <a:p>
+            <a:pPr algn="l"/>
+            <a:r>
+              <a:rPr sz="750" b="1">
+                <a:solidFill>
+                  <a:srgbClr val="0E7090"/>
+                </a:solidFill>
+                <a:latin typeface="Calibri"/>
+              </a:rPr>
+              <a:t>ASSET: slides/GATE-2/AEGIS_Gate2_Official.pptx, Slide 6 (PASS/STEP-UP/BLOCK pills)</a:t>
             </a:r>
           </a:p>
         </p:txBody>
@@ -15261,7 +15537,7 @@
           <a:p>
             <a:pPr algn="l"/>
             <a:r>
-              <a:rPr sz="900" b="1">
+              <a:rPr sz="850" b="1">
                 <a:solidFill>
                   <a:srgbClr val="020C31"/>
                 </a:solidFill>
@@ -15273,13 +15549,25 @@
           <a:p>
             <a:pPr algn="l"/>
             <a:r>
-              <a:rPr sz="850" i="1">
+              <a:rPr sz="800" i="1">
                 <a:solidFill>
                   <a:srgbClr val="555555"/>
                 </a:solidFill>
                 <a:latin typeface="Calibri"/>
               </a:rPr>
               <a:t>Never trust. Always verify. Continuously.</a:t>
+            </a:r>
+          </a:p>
+          <a:p>
+            <a:pPr algn="l"/>
+            <a:r>
+              <a:rPr sz="750" b="1">
+                <a:solidFill>
+                  <a:srgbClr val="0E7090"/>
+                </a:solidFill>
+                <a:latin typeface="Calibri"/>
+              </a:rPr>
+              <a:t>NEW: text card (quote README's zero-trust framing)</a:t>
             </a:r>
           </a:p>
         </p:txBody>
@@ -18038,7 +18326,7 @@
           <a:p>
             <a:pPr algn="l"/>
             <a:r>
-              <a:rPr sz="900" b="1">
+              <a:rPr sz="850" b="1">
                 <a:solidFill>
                   <a:srgbClr val="020C31"/>
                 </a:solidFill>
@@ -18050,13 +18338,25 @@
           <a:p>
             <a:pPr algn="l"/>
             <a:r>
-              <a:rPr sz="850" i="1">
+              <a:rPr sz="800" i="1">
                 <a:solidFill>
                   <a:srgbClr val="555555"/>
                 </a:solidFill>
                 <a:latin typeface="Calibri"/>
               </a:rPr>
               <a:t>Here it is, live - not a mockup.</a:t>
+            </a:r>
+          </a:p>
+          <a:p>
+            <a:pPr algn="l"/>
+            <a:r>
+              <a:rPr sz="750" b="1">
+                <a:solidFill>
+                  <a:srgbClr val="0E7090"/>
+                </a:solidFill>
+                <a:latin typeface="Calibri"/>
+              </a:rPr>
+              <a:t>ASSET: live screen recording of aegis5gacademy.streamlit.app, OR slides/GATE-2/AEGIS_Live_Demo.mp4</a:t>
             </a:r>
           </a:p>
         </p:txBody>
@@ -18085,7 +18385,7 @@
           <a:p>
             <a:pPr algn="l"/>
             <a:r>
-              <a:rPr sz="900" b="1">
+              <a:rPr sz="850" b="1">
                 <a:solidFill>
                   <a:srgbClr val="020C31"/>
                 </a:solidFill>
@@ -18097,13 +18397,25 @@
           <a:p>
             <a:pPr algn="l"/>
             <a:r>
-              <a:rPr sz="850" i="1">
+              <a:rPr sz="800" i="1">
                 <a:solidFill>
                   <a:srgbClr val="555555"/>
                 </a:solidFill>
                 <a:latin typeface="Calibri"/>
               </a:rPr>
               <a:t>Watch what happens when an agent starts behaving like an attacker.</a:t>
+            </a:r>
+          </a:p>
+          <a:p>
+            <a:pPr algn="l"/>
+            <a:r>
+              <a:rPr sz="750" b="1">
+                <a:solidFill>
+                  <a:srgbClr val="0E7090"/>
+                </a:solidFill>
+                <a:latin typeface="Calibri"/>
+              </a:rPr>
+              <a:t>ASSET: slides/GATE-2/AEGIS_Live_Demo.mp4 (attack-injection segment)</a:t>
             </a:r>
           </a:p>
         </p:txBody>
@@ -18132,7 +18444,7 @@
           <a:p>
             <a:pPr algn="l"/>
             <a:r>
-              <a:rPr sz="900" b="1">
+              <a:rPr sz="850" b="1">
                 <a:solidFill>
                   <a:srgbClr val="020C31"/>
                 </a:solidFill>
@@ -18144,13 +18456,25 @@
           <a:p>
             <a:pPr algn="l"/>
             <a:r>
-              <a:rPr sz="850" i="1">
+              <a:rPr sz="800" i="1">
                 <a:solidFill>
                   <a:srgbClr val="555555"/>
                 </a:solidFill>
                 <a:latin typeface="Calibri"/>
               </a:rPr>
               <a:t>Probing endpoints it's never touched, at a rate it's never used.</a:t>
+            </a:r>
+          </a:p>
+          <a:p>
+            <a:pPr algn="l"/>
+            <a:r>
+              <a:rPr sz="750" b="1">
+                <a:solidFill>
+                  <a:srgbClr val="0E7090"/>
+                </a:solidFill>
+                <a:latin typeface="Calibri"/>
+              </a:rPr>
+              <a:t>ASSET: slides/GATE-2/AEGIS_Live_Demo.mp4 (same segment, continued)</a:t>
             </a:r>
           </a:p>
         </p:txBody>
@@ -18179,7 +18503,7 @@
           <a:p>
             <a:pPr algn="l"/>
             <a:r>
-              <a:rPr sz="900" b="1">
+              <a:rPr sz="850" b="1">
                 <a:solidFill>
                   <a:srgbClr val="020C31"/>
                 </a:solidFill>
@@ -18191,13 +18515,25 @@
           <a:p>
             <a:pPr algn="l"/>
             <a:r>
-              <a:rPr sz="850" i="1">
+              <a:rPr sz="800" i="1">
                 <a:solidFill>
                   <a:srgbClr val="555555"/>
                 </a:solidFill>
                 <a:latin typeface="Calibri"/>
               </a:rPr>
               <a:t>AEGIS explains exactly why, in language a security analyst can act on.</a:t>
+            </a:r>
+          </a:p>
+          <a:p>
+            <a:pPr algn="l"/>
+            <a:r>
+              <a:rPr sz="750" b="1">
+                <a:solidFill>
+                  <a:srgbClr val="0E7090"/>
+                </a:solidFill>
+                <a:latin typeface="Calibri"/>
+              </a:rPr>
+              <a:t>ASSET: live screen recording - incident inspector panel</a:t>
             </a:r>
           </a:p>
         </p:txBody>
@@ -18226,7 +18562,7 @@
           <a:p>
             <a:pPr algn="l"/>
             <a:r>
-              <a:rPr sz="900" b="1">
+              <a:rPr sz="850" b="1">
                 <a:solidFill>
                   <a:srgbClr val="020C31"/>
                 </a:solidFill>
@@ -18238,13 +18574,25 @@
           <a:p>
             <a:pPr algn="l"/>
             <a:r>
-              <a:rPr sz="850" i="1">
+              <a:rPr sz="800" i="1">
                 <a:solidFill>
                   <a:srgbClr val="555555"/>
                 </a:solidFill>
                 <a:latin typeface="Calibri"/>
               </a:rPr>
               <a:t>And shuts it down before real damage is done.</a:t>
+            </a:r>
+          </a:p>
+          <a:p>
+            <a:pPr algn="l"/>
+            <a:r>
+              <a:rPr sz="750" b="1">
+                <a:solidFill>
+                  <a:srgbClr val="0E7090"/>
+                </a:solidFill>
+                <a:latin typeface="Calibri"/>
+              </a:rPr>
+              <a:t>ASSET: slides/GATE-2/AEGIS_Live_Demo.mp4 (decision moment)</a:t>
             </a:r>
           </a:p>
         </p:txBody>
@@ -18273,7 +18621,7 @@
           <a:p>
             <a:pPr algn="l"/>
             <a:r>
-              <a:rPr sz="900" b="1">
+              <a:rPr sz="850" b="1">
                 <a:solidFill>
                   <a:srgbClr val="020C31"/>
                 </a:solidFill>
@@ -18285,13 +18633,25 @@
           <a:p>
             <a:pPr algn="l"/>
             <a:r>
-              <a:rPr sz="850" i="1">
+              <a:rPr sz="800" i="1">
                 <a:solidFill>
                   <a:srgbClr val="555555"/>
                 </a:solidFill>
                 <a:latin typeface="Calibri"/>
               </a:rPr>
               <a:t>This is the difference AEGIS makes.</a:t>
+            </a:r>
+          </a:p>
+          <a:p>
+            <a:pPr algn="l"/>
+            <a:r>
+              <a:rPr sz="750" b="1">
+                <a:solidFill>
+                  <a:srgbClr val="0E7090"/>
+                </a:solidFill>
+                <a:latin typeface="Calibri"/>
+              </a:rPr>
+              <a:t>ASSET: slides/GATE-2/AEGIS_Live_Demo.mp4 (before/after segment)</a:t>
             </a:r>
           </a:p>
         </p:txBody>
@@ -21029,7 +21389,7 @@
           <a:p>
             <a:pPr algn="l"/>
             <a:r>
-              <a:rPr sz="900" b="1">
+              <a:rPr sz="850" b="1">
                 <a:solidFill>
                   <a:srgbClr val="020C31"/>
                 </a:solidFill>
@@ -21041,13 +21401,25 @@
           <a:p>
             <a:pPr algn="l"/>
             <a:r>
-              <a:rPr sz="850" i="1">
+              <a:rPr sz="800" i="1">
                 <a:solidFill>
                   <a:srgbClr val="555555"/>
                 </a:solidFill>
                 <a:latin typeface="Calibri"/>
               </a:rPr>
               <a:t>We didn't stop at simulation.</a:t>
+            </a:r>
+          </a:p>
+          <a:p>
+            <a:pPr algn="l"/>
+            <a:r>
+              <a:rPr sz="750" b="1">
+                <a:solidFill>
+                  <a:srgbClr val="0E7090"/>
+                </a:solidFill>
+                <a:latin typeface="Calibri"/>
+              </a:rPr>
+              <a:t>NEW: live screen recording (docker compose up on open5gs-testbed)</a:t>
             </a:r>
           </a:p>
         </p:txBody>
@@ -21076,7 +21448,7 @@
           <a:p>
             <a:pPr algn="l"/>
             <a:r>
-              <a:rPr sz="900" b="1">
+              <a:rPr sz="850" b="1">
                 <a:solidFill>
                   <a:srgbClr val="020C31"/>
                 </a:solidFill>
@@ -21088,13 +21460,25 @@
           <a:p>
             <a:pPr algn="l"/>
             <a:r>
-              <a:rPr sz="850" i="1">
+              <a:rPr sz="800" i="1">
                 <a:solidFill>
                   <a:srgbClr val="555555"/>
                 </a:solidFill>
                 <a:latin typeface="Calibri"/>
               </a:rPr>
               <a:t>We built a real 5G core.</a:t>
+            </a:r>
+          </a:p>
+          <a:p>
+            <a:pPr algn="l"/>
+            <a:r>
+              <a:rPr sz="750" b="1">
+                <a:solidFill>
+                  <a:srgbClr val="0E7090"/>
+                </a:solidFill>
+                <a:latin typeface="Calibri"/>
+              </a:rPr>
+              <a:t>ASSET: slides/GATE-2/AEGIS_Gate2_Official.pptx, Slide 17 (Real M2M/API-gateway diagram)</a:t>
             </a:r>
           </a:p>
         </p:txBody>
@@ -21123,7 +21507,7 @@
           <a:p>
             <a:pPr algn="l"/>
             <a:r>
-              <a:rPr sz="900" b="1">
+              <a:rPr sz="850" b="1">
                 <a:solidFill>
                   <a:srgbClr val="020C31"/>
                 </a:solidFill>
@@ -21135,13 +21519,25 @@
           <a:p>
             <a:pPr algn="l"/>
             <a:r>
-              <a:rPr sz="850" i="1">
+              <a:rPr sz="800" i="1">
                 <a:solidFill>
                   <a:srgbClr val="555555"/>
                 </a:solidFill>
                 <a:latin typeface="Calibri"/>
               </a:rPr>
               <a:t>Connected a real device to it.</a:t>
+            </a:r>
+          </a:p>
+          <a:p>
+            <a:pPr algn="l"/>
+            <a:r>
+              <a:rPr sz="750" b="1">
+                <a:solidFill>
+                  <a:srgbClr val="0E7090"/>
+                </a:solidFill>
+                <a:latin typeface="Calibri"/>
+              </a:rPr>
+              <a:t>NEW: live screen recording (docker logs nr_ue - real UE registration)</a:t>
             </a:r>
           </a:p>
         </p:txBody>
@@ -21170,7 +21566,7 @@
           <a:p>
             <a:pPr algn="l"/>
             <a:r>
-              <a:rPr sz="900" b="1">
+              <a:rPr sz="850" b="1">
                 <a:solidFill>
                   <a:srgbClr val="020C31"/>
                 </a:solidFill>
@@ -21182,13 +21578,25 @@
           <a:p>
             <a:pPr algn="l"/>
             <a:r>
-              <a:rPr sz="850" i="1">
+              <a:rPr sz="800" i="1">
                 <a:solidFill>
                   <a:srgbClr val="555555"/>
                 </a:solidFill>
                 <a:latin typeface="Calibri"/>
               </a:rPr>
               <a:t>And tested AEGIS against real network traffic.</a:t>
+            </a:r>
+          </a:p>
+          <a:p>
+            <a:pPr algn="l"/>
+            <a:r>
+              <a:rPr sz="750" b="1">
+                <a:solidFill>
+                  <a:srgbClr val="0E7090"/>
+                </a:solidFill>
+                <a:latin typeface="Calibri"/>
+              </a:rPr>
+              <a:t>ASSET: reports/GATE-3/real_sbi_capture.csv (screenshot/graphic)</a:t>
             </a:r>
           </a:p>
         </p:txBody>
@@ -21217,7 +21625,7 @@
           <a:p>
             <a:pPr algn="l"/>
             <a:r>
-              <a:rPr sz="900" b="1">
+              <a:rPr sz="850" b="1">
                 <a:solidFill>
                   <a:srgbClr val="020C31"/>
                 </a:solidFill>
@@ -21229,13 +21637,25 @@
           <a:p>
             <a:pPr algn="l"/>
             <a:r>
-              <a:rPr sz="850" i="1">
+              <a:rPr sz="800" i="1">
                 <a:solidFill>
                   <a:srgbClr val="555555"/>
                 </a:solidFill>
                 <a:latin typeface="Calibri"/>
               </a:rPr>
               <a:t>The exact same detection code. No changes. It worked.</a:t>
+            </a:r>
+          </a:p>
+          <a:p>
+            <a:pPr algn="l"/>
+            <a:r>
+              <a:rPr sz="750" b="1">
+                <a:solidFill>
+                  <a:srgbClr val="0E7090"/>
+                </a:solidFill>
+                <a:latin typeface="Calibri"/>
+              </a:rPr>
+              <a:t>NEW: graphic from validate_real_traffic_detection.py output (2/2 BLOCK result)</a:t>
             </a:r>
           </a:p>
         </p:txBody>
@@ -21264,7 +21684,7 @@
           <a:p>
             <a:pPr algn="l"/>
             <a:r>
-              <a:rPr sz="900" b="1">
+              <a:rPr sz="850" b="1">
                 <a:solidFill>
                   <a:srgbClr val="020C31"/>
                 </a:solidFill>
@@ -21276,13 +21696,25 @@
           <a:p>
             <a:pPr algn="l"/>
             <a:r>
-              <a:rPr sz="850" i="1">
+              <a:rPr sz="800" i="1">
                 <a:solidFill>
                   <a:srgbClr val="555555"/>
                 </a:solidFill>
                 <a:latin typeface="Calibri"/>
               </a:rPr>
               <a:t>Benchmarked, not just claimed.</a:t>
+            </a:r>
+          </a:p>
+          <a:p>
+            <a:pPr algn="l"/>
+            <a:r>
+              <a:rPr sz="750" b="1">
+                <a:solidFill>
+                  <a:srgbClr val="0E7090"/>
+                </a:solidFill>
+                <a:latin typeface="Calibri"/>
+              </a:rPr>
+              <a:t>ASSET: reports/aegis_eval.png, updated with Gate 3 numbers</a:t>
             </a:r>
           </a:p>
         </p:txBody>
@@ -24100,7 +24532,7 @@
           <a:p>
             <a:pPr algn="l"/>
             <a:r>
-              <a:rPr sz="900" b="1">
+              <a:rPr sz="850" b="1">
                 <a:solidFill>
                   <a:srgbClr val="020C31"/>
                 </a:solidFill>
@@ -24112,13 +24544,25 @@
           <a:p>
             <a:pPr algn="l"/>
             <a:r>
-              <a:rPr sz="850" i="1">
+              <a:rPr sz="800" i="1">
                 <a:solidFill>
                   <a:srgbClr val="555555"/>
                 </a:solidFill>
                 <a:latin typeface="Calibri"/>
               </a:rPr>
               <a:t>Every decision AEGIS makes comes with a plain-language reason.</a:t>
+            </a:r>
+          </a:p>
+          <a:p>
+            <a:pPr algn="l"/>
+            <a:r>
+              <a:rPr sz="750" b="1">
+                <a:solidFill>
+                  <a:srgbClr val="0E7090"/>
+                </a:solidFill>
+                <a:latin typeface="Calibri"/>
+              </a:rPr>
+              <a:t>NEW: text card</a:t>
             </a:r>
           </a:p>
         </p:txBody>
@@ -24147,7 +24591,7 @@
           <a:p>
             <a:pPr algn="l"/>
             <a:r>
-              <a:rPr sz="900" b="1">
+              <a:rPr sz="850" b="1">
                 <a:solidFill>
                   <a:srgbClr val="020C31"/>
                 </a:solidFill>
@@ -24159,13 +24603,25 @@
           <a:p>
             <a:pPr algn="l"/>
             <a:r>
-              <a:rPr sz="850" i="1">
+              <a:rPr sz="800" i="1">
                 <a:solidFill>
                   <a:srgbClr val="555555"/>
                 </a:solidFill>
                 <a:latin typeface="Calibri"/>
               </a:rPr>
               <a:t>No guessing at why an alert fired.</a:t>
+            </a:r>
+          </a:p>
+          <a:p>
+            <a:pPr algn="l"/>
+            <a:r>
+              <a:rPr sz="750" b="1">
+                <a:solidFill>
+                  <a:srgbClr val="0E7090"/>
+                </a:solidFill>
+                <a:latin typeface="Calibri"/>
+              </a:rPr>
+              <a:t>ASSET: live screen recording - incident inspector panel (reuse from scene 5)</a:t>
             </a:r>
           </a:p>
         </p:txBody>
@@ -24194,7 +24650,7 @@
           <a:p>
             <a:pPr algn="l"/>
             <a:r>
-              <a:rPr sz="900" b="1">
+              <a:rPr sz="850" b="1">
                 <a:solidFill>
                   <a:srgbClr val="020C31"/>
                 </a:solidFill>
@@ -24206,13 +24662,25 @@
           <a:p>
             <a:pPr algn="l"/>
             <a:r>
-              <a:rPr sz="850" i="1">
+              <a:rPr sz="800" i="1">
                 <a:solidFill>
                   <a:srgbClr val="555555"/>
                 </a:solidFill>
                 <a:latin typeface="Calibri"/>
               </a:rPr>
               <a:t>Subscriber identifiers are protected, never stored raw.</a:t>
+            </a:r>
+          </a:p>
+          <a:p>
+            <a:pPr algn="l"/>
+            <a:r>
+              <a:rPr sz="750" b="1">
+                <a:solidFill>
+                  <a:srgbClr val="0E7090"/>
+                </a:solidFill>
+                <a:latin typeface="Calibri"/>
+              </a:rPr>
+              <a:t>NEW: graphic - concept from docs/GATE-3/real-vs-synthetic-dashboard-implications.md (privacy section)</a:t>
             </a:r>
           </a:p>
         </p:txBody>
@@ -24241,13 +24709,25 @@
           <a:p>
             <a:pPr algn="l"/>
             <a:r>
-              <a:rPr sz="900" b="1">
+              <a:rPr sz="850" b="1">
                 <a:solidFill>
                   <a:srgbClr val="020C31"/>
                 </a:solidFill>
                 <a:latin typeface="Calibri"/>
               </a:rPr>
               <a:t>[STACCO - hard cut]</a:t>
+            </a:r>
+          </a:p>
+          <a:p>
+            <a:pPr algn="l"/>
+            <a:r>
+              <a:rPr sz="750" b="1">
+                <a:solidFill>
+                  <a:srgbClr val="0E7090"/>
+                </a:solidFill>
+                <a:latin typeface="Calibri"/>
+              </a:rPr>
+              <a:t>N/A - transition only</a:t>
             </a:r>
           </a:p>
         </p:txBody>
@@ -24276,7 +24756,7 @@
           <a:p>
             <a:pPr algn="l"/>
             <a:r>
-              <a:rPr sz="900" b="1">
+              <a:rPr sz="850" b="1">
                 <a:solidFill>
                   <a:srgbClr val="020C31"/>
                 </a:solidFill>
@@ -24288,13 +24768,25 @@
           <a:p>
             <a:pPr algn="l"/>
             <a:r>
-              <a:rPr sz="850" i="1">
+              <a:rPr sz="800" i="1">
                 <a:solidFill>
                   <a:srgbClr val="555555"/>
                 </a:solidFill>
                 <a:latin typeface="Calibri"/>
               </a:rPr>
               <a:t>In production, AEGIS runs at the network edge - close to the core, low latency.</a:t>
+            </a:r>
+          </a:p>
+          <a:p>
+            <a:pPr algn="l"/>
+            <a:r>
+              <a:rPr sz="750" b="1">
+                <a:solidFill>
+                  <a:srgbClr val="0E7090"/>
+                </a:solidFill>
+                <a:latin typeface="Calibri"/>
+              </a:rPr>
+              <a:t>NEW: graphic - concept from docs/GATE-3/real-vs-synthetic-dashboard-implications.md (production section)</a:t>
             </a:r>
           </a:p>
         </p:txBody>
@@ -24323,7 +24815,7 @@
           <a:p>
             <a:pPr algn="l"/>
             <a:r>
-              <a:rPr sz="900" b="1">
+              <a:rPr sz="850" b="1">
                 <a:solidFill>
                   <a:srgbClr val="020C31"/>
                 </a:solidFill>
@@ -24335,13 +24827,25 @@
           <a:p>
             <a:pPr algn="l"/>
             <a:r>
-              <a:rPr sz="850" i="1">
+              <a:rPr sz="800" i="1">
                 <a:solidFill>
                   <a:srgbClr val="555555"/>
                 </a:solidFill>
                 <a:latin typeface="Calibri"/>
               </a:rPr>
               <a:t>Security that explains itself, built to be trusted, not just deployed.</a:t>
+            </a:r>
+          </a:p>
+          <a:p>
+            <a:pPr algn="l"/>
+            <a:r>
+              <a:rPr sz="750" b="1">
+                <a:solidFill>
+                  <a:srgbClr val="0E7090"/>
+                </a:solidFill>
+                <a:latin typeface="Calibri"/>
+              </a:rPr>
+              <a:t>NEW: text card</a:t>
             </a:r>
           </a:p>
         </p:txBody>
@@ -27092,7 +27596,7 @@
           <a:p>
             <a:pPr algn="l"/>
             <a:r>
-              <a:rPr sz="900" b="1">
+              <a:rPr sz="850" b="1">
                 <a:solidFill>
                   <a:srgbClr val="020C31"/>
                 </a:solidFill>
@@ -27104,13 +27608,25 @@
           <a:p>
             <a:pPr algn="l"/>
             <a:r>
-              <a:rPr sz="850" i="1">
+              <a:rPr sz="800" i="1">
                 <a:solidFill>
                   <a:srgbClr val="555555"/>
                 </a:solidFill>
                 <a:latin typeface="Calibri"/>
               </a:rPr>
               <a:t>Recap montage - the whole story in five seconds.</a:t>
+            </a:r>
+          </a:p>
+          <a:p>
+            <a:pPr algn="l"/>
+            <a:r>
+              <a:rPr sz="750" b="1">
+                <a:solidFill>
+                  <a:srgbClr val="0E7090"/>
+                </a:solidFill>
+                <a:latin typeface="Calibri"/>
+              </a:rPr>
+              <a:t>ASSET: re-cut of scenes 1, 5, 6 above</a:t>
             </a:r>
           </a:p>
         </p:txBody>
@@ -27139,7 +27655,7 @@
           <a:p>
             <a:pPr algn="l"/>
             <a:r>
-              <a:rPr sz="900" b="1">
+              <a:rPr sz="850" b="1">
                 <a:solidFill>
                   <a:srgbClr val="020C31"/>
                 </a:solidFill>
@@ -27151,13 +27667,25 @@
           <a:p>
             <a:pPr algn="l"/>
             <a:r>
-              <a:rPr sz="850" i="1">
+              <a:rPr sz="800" i="1">
                 <a:solidFill>
                   <a:srgbClr val="555555"/>
                 </a:solidFill>
                 <a:latin typeface="Calibri"/>
               </a:rPr>
               <a:t>"Trust can't be a one-time check."</a:t>
+            </a:r>
+          </a:p>
+          <a:p>
+            <a:pPr algn="l"/>
+            <a:r>
+              <a:rPr sz="750" b="1">
+                <a:solidFill>
+                  <a:srgbClr val="0E7090"/>
+                </a:solidFill>
+                <a:latin typeface="Calibri"/>
+              </a:rPr>
+              <a:t>NEW: text card</a:t>
             </a:r>
           </a:p>
         </p:txBody>
@@ -27186,7 +27714,7 @@
           <a:p>
             <a:pPr algn="l"/>
             <a:r>
-              <a:rPr sz="900" b="1">
+              <a:rPr sz="850" b="1">
                 <a:solidFill>
                   <a:srgbClr val="020C31"/>
                 </a:solidFill>
@@ -27198,13 +27726,25 @@
           <a:p>
             <a:pPr algn="l"/>
             <a:r>
-              <a:rPr sz="850" i="1">
+              <a:rPr sz="800" i="1">
                 <a:solidFill>
                   <a:srgbClr val="555555"/>
                 </a:solidFill>
                 <a:latin typeface="Calibri"/>
               </a:rPr>
               <a:t>"It has to be continuous."</a:t>
+            </a:r>
+          </a:p>
+          <a:p>
+            <a:pPr algn="l"/>
+            <a:r>
+              <a:rPr sz="750" b="1">
+                <a:solidFill>
+                  <a:srgbClr val="0E7090"/>
+                </a:solidFill>
+                <a:latin typeface="Calibri"/>
+              </a:rPr>
+              <a:t>NEW: text card</a:t>
             </a:r>
           </a:p>
         </p:txBody>
@@ -27233,7 +27773,7 @@
           <a:p>
             <a:pPr algn="l"/>
             <a:r>
-              <a:rPr sz="900" b="1">
+              <a:rPr sz="850" b="1">
                 <a:solidFill>
                   <a:srgbClr val="020C31"/>
                 </a:solidFill>
@@ -27245,13 +27785,25 @@
           <a:p>
             <a:pPr algn="l"/>
             <a:r>
-              <a:rPr sz="850" i="1">
+              <a:rPr sz="800" i="1">
                 <a:solidFill>
                   <a:srgbClr val="555555"/>
                 </a:solidFill>
                 <a:latin typeface="Calibri"/>
               </a:rPr>
               <a:t>aegis5gacademy.streamlit.app - see it live.</a:t>
+            </a:r>
+          </a:p>
+          <a:p>
+            <a:pPr algn="l"/>
+            <a:r>
+              <a:rPr sz="750" b="1">
+                <a:solidFill>
+                  <a:srgbClr val="0E7090"/>
+                </a:solidFill>
+                <a:latin typeface="Calibri"/>
+              </a:rPr>
+              <a:t>ASSET: slides/GATE-2/AEGIS_Gate2_Official.pptx, Slide 19 (Thank You, has GitHub/dashboard links)</a:t>
             </a:r>
           </a:p>
         </p:txBody>
@@ -27280,7 +27832,7 @@
           <a:p>
             <a:pPr algn="l"/>
             <a:r>
-              <a:rPr sz="900" b="1">
+              <a:rPr sz="850" b="1">
                 <a:solidFill>
                   <a:srgbClr val="020C31"/>
                 </a:solidFill>
@@ -27292,13 +27844,25 @@
           <a:p>
             <a:pPr algn="l"/>
             <a:r>
-              <a:rPr sz="850" i="1">
+              <a:rPr sz="800" i="1">
                 <a:solidFill>
                   <a:srgbClr val="555555"/>
                 </a:solidFill>
                 <a:latin typeface="Calibri"/>
               </a:rPr>
               <a:t>5G Academy 2026, in partnership with Fastweb and Vodafone.</a:t>
+            </a:r>
+          </a:p>
+          <a:p>
+            <a:pPr algn="l"/>
+            <a:r>
+              <a:rPr sz="750" b="1">
+                <a:solidFill>
+                  <a:srgbClr val="0E7090"/>
+                </a:solidFill>
+                <a:latin typeface="Calibri"/>
+              </a:rPr>
+              <a:t>ASSET: slides/GATE-2/AEGIS_Gate2_Official.pptx, Slide 1 (branding)</a:t>
             </a:r>
           </a:p>
         </p:txBody>
@@ -27327,7 +27891,7 @@
           <a:p>
             <a:pPr algn="l"/>
             <a:r>
-              <a:rPr sz="900" b="1">
+              <a:rPr sz="850" b="1">
                 <a:solidFill>
                   <a:srgbClr val="020C31"/>
                 </a:solidFill>
@@ -27339,13 +27903,25 @@
           <a:p>
             <a:pPr algn="l"/>
             <a:r>
-              <a:rPr sz="850" i="1">
+              <a:rPr sz="800" i="1">
                 <a:solidFill>
                   <a:srgbClr val="555555"/>
                 </a:solidFill>
                 <a:latin typeface="Calibri"/>
               </a:rPr>
               <a:t>Thank you.</a:t>
+            </a:r>
+          </a:p>
+          <a:p>
+            <a:pPr algn="l"/>
+            <a:r>
+              <a:rPr sz="750" b="1">
+                <a:solidFill>
+                  <a:srgbClr val="0E7090"/>
+                </a:solidFill>
+                <a:latin typeface="Calibri"/>
+              </a:rPr>
+              <a:t>N/A - transition only</a:t>
             </a:r>
           </a:p>
         </p:txBody>

</xml_diff>

<commit_message>
Insert real project images into the storyboard panels
Adds a script that inserts existing images directly into the sketch
panels of the already-filled storyboard, matching last year's example
pattern (a picture placed over each panel, sized to fit). Operates on
the existing file in place rather than regenerating from the template,
so the manually-fixed team slide (page 9) is untouched.

8 panels filled with real assets: the architecture diagram (3 spots),
the badge/network hook graphic (2 spots), and the real dashboard
screenshot + evaluation chart for the live-demo and results sections.

Not yet covered (needs manual capture, not automatable here): the
network topology view, the incident inspector panel, a live
attack-injection click-through, and the Open5GS terminal footage - all
genuinely need a live session, not a static asset.
</commit_message>
<xml_diff>
--- a/slides/GATE-3/AEGIS_Gate3_Storyboard.pptx
+++ b/slides/GATE-3/AEGIS_Gate3_Storyboard.pptx
@@ -5811,7 +5811,7 @@
         </p:nvSpPr>
         <p:spPr>
           <a:xfrm>
-            <a:off x="365811" y="239475"/>
+            <a:off x="73342" y="100951"/>
             <a:ext cx="328295" cy="187325"/>
           </a:xfrm>
           <a:prstGeom prst="rect">
@@ -5833,7 +5833,7 @@
               </a:spcAft>
             </a:pPr>
             <a:r>
-              <a:rPr lang="en-US" sz="1100" kern="1200" spc="-40">
+              <a:rPr lang="en-US" sz="1100" kern="1200" spc="-40" dirty="0">
                 <a:solidFill>
                   <a:srgbClr val="9B9B9B"/>
                 </a:solidFill>
@@ -5844,7 +5844,7 @@
               </a:rPr>
               <a:t>Title: AEGIS - Zero-Trust Identity for AI Agents</a:t>
             </a:r>
-            <a:endParaRPr lang="en-US" sz="1100">
+            <a:endParaRPr lang="en-US" sz="1100" dirty="0">
               <a:effectLst/>
               <a:latin typeface="Arial" panose="020B0604020202020204" pitchFamily="34" charset="0"/>
               <a:ea typeface="Times New Roman" panose="02020603050405020304" pitchFamily="18" charset="0"/>
@@ -5995,7 +5995,7 @@
           <a:noFill/>
         </p:spPr>
         <p:txBody>
-          <a:bodyPr wrap="square" lIns="0" rIns="0" tIns="0" bIns="0">
+          <a:bodyPr wrap="square" lIns="0" tIns="0" rIns="0" bIns="0">
             <a:spAutoFit/>
           </a:bodyPr>
           <a:lstStyle/>
@@ -6054,7 +6054,7 @@
           <a:noFill/>
         </p:spPr>
         <p:txBody>
-          <a:bodyPr wrap="square" lIns="0" rIns="0" tIns="0" bIns="0">
+          <a:bodyPr wrap="square" lIns="0" tIns="0" rIns="0" bIns="0">
             <a:spAutoFit/>
           </a:bodyPr>
           <a:lstStyle/>
@@ -6113,7 +6113,7 @@
           <a:noFill/>
         </p:spPr>
         <p:txBody>
-          <a:bodyPr wrap="square" lIns="0" rIns="0" tIns="0" bIns="0">
+          <a:bodyPr wrap="square" lIns="0" tIns="0" rIns="0" bIns="0">
             <a:spAutoFit/>
           </a:bodyPr>
           <a:lstStyle/>
@@ -6172,7 +6172,7 @@
           <a:noFill/>
         </p:spPr>
         <p:txBody>
-          <a:bodyPr wrap="square" lIns="0" rIns="0" tIns="0" bIns="0">
+          <a:bodyPr wrap="square" lIns="0" tIns="0" rIns="0" bIns="0">
             <a:spAutoFit/>
           </a:bodyPr>
           <a:lstStyle/>
@@ -6231,7 +6231,7 @@
           <a:noFill/>
         </p:spPr>
         <p:txBody>
-          <a:bodyPr wrap="square" lIns="0" rIns="0" tIns="0" bIns="0">
+          <a:bodyPr wrap="square" lIns="0" tIns="0" rIns="0" bIns="0">
             <a:spAutoFit/>
           </a:bodyPr>
           <a:lstStyle/>
@@ -6290,7 +6290,7 @@
           <a:noFill/>
         </p:spPr>
         <p:txBody>
-          <a:bodyPr wrap="square" lIns="0" rIns="0" tIns="0" bIns="0">
+          <a:bodyPr wrap="square" lIns="0" tIns="0" rIns="0" bIns="0">
             <a:spAutoFit/>
           </a:bodyPr>
           <a:lstStyle/>
@@ -6332,6 +6332,54 @@
           </a:p>
         </p:txBody>
       </p:sp>
+      <p:pic>
+        <p:nvPicPr>
+          <p:cNvPr id="71" name="Picture 70" descr="architecture.png"/>
+          <p:cNvPicPr>
+            <a:picLocks noChangeAspect="1"/>
+          </p:cNvPicPr>
+          <p:nvPr/>
+        </p:nvPicPr>
+        <p:blipFill>
+          <a:blip r:embed="rId3"/>
+          <a:stretch>
+            <a:fillRect/>
+          </a:stretch>
+        </p:blipFill>
+        <p:spPr>
+          <a:xfrm>
+            <a:off x="8083712" y="696595"/>
+            <a:ext cx="1490655" cy="2070100"/>
+          </a:xfrm>
+          <a:prstGeom prst="rect">
+            <a:avLst/>
+          </a:prstGeom>
+        </p:spPr>
+      </p:pic>
+      <p:pic>
+        <p:nvPicPr>
+          <p:cNvPr id="72" name="Picture 71" descr="aegis_hook_analogy.png"/>
+          <p:cNvPicPr>
+            <a:picLocks noChangeAspect="1"/>
+          </p:cNvPicPr>
+          <p:nvPr/>
+        </p:nvPicPr>
+        <p:blipFill>
+          <a:blip r:embed="rId4"/>
+          <a:stretch>
+            <a:fillRect/>
+          </a:stretch>
+        </p:blipFill>
+        <p:spPr>
+          <a:xfrm>
+            <a:off x="237490" y="4608217"/>
+            <a:ext cx="3187700" cy="723856"/>
+          </a:xfrm>
+          <a:prstGeom prst="rect">
+            <a:avLst/>
+          </a:prstGeom>
+        </p:spPr>
+      </p:pic>
     </p:spTree>
     <p:extLst>
       <p:ext uri="{BB962C8B-B14F-4D97-AF65-F5344CB8AC3E}">
@@ -9058,7 +9106,7 @@
           <a:noFill/>
         </p:spPr>
         <p:txBody>
-          <a:bodyPr wrap="square" lIns="0" rIns="0" tIns="0" bIns="0">
+          <a:bodyPr wrap="square" lIns="0" tIns="0" rIns="0" bIns="0">
             <a:spAutoFit/>
           </a:bodyPr>
           <a:lstStyle/>
@@ -9117,7 +9165,7 @@
           <a:noFill/>
         </p:spPr>
         <p:txBody>
-          <a:bodyPr wrap="square" lIns="0" rIns="0" tIns="0" bIns="0">
+          <a:bodyPr wrap="square" lIns="0" tIns="0" rIns="0" bIns="0">
             <a:spAutoFit/>
           </a:bodyPr>
           <a:lstStyle/>
@@ -9176,7 +9224,7 @@
           <a:noFill/>
         </p:spPr>
         <p:txBody>
-          <a:bodyPr wrap="square" lIns="0" rIns="0" tIns="0" bIns="0">
+          <a:bodyPr wrap="square" lIns="0" tIns="0" rIns="0" bIns="0">
             <a:spAutoFit/>
           </a:bodyPr>
           <a:lstStyle/>
@@ -9235,7 +9283,7 @@
           <a:noFill/>
         </p:spPr>
         <p:txBody>
-          <a:bodyPr wrap="square" lIns="0" rIns="0" tIns="0" bIns="0">
+          <a:bodyPr wrap="square" lIns="0" tIns="0" rIns="0" bIns="0">
             <a:spAutoFit/>
           </a:bodyPr>
           <a:lstStyle/>
@@ -9294,7 +9342,7 @@
           <a:noFill/>
         </p:spPr>
         <p:txBody>
-          <a:bodyPr wrap="square" lIns="0" rIns="0" tIns="0" bIns="0">
+          <a:bodyPr wrap="square" lIns="0" tIns="0" rIns="0" bIns="0">
             <a:spAutoFit/>
           </a:bodyPr>
           <a:lstStyle/>
@@ -9353,7 +9401,7 @@
           <a:noFill/>
         </p:spPr>
         <p:txBody>
-          <a:bodyPr wrap="square" lIns="0" rIns="0" tIns="0" bIns="0">
+          <a:bodyPr wrap="square" lIns="0" tIns="0" rIns="0" bIns="0">
             <a:spAutoFit/>
           </a:bodyPr>
           <a:lstStyle/>
@@ -9383,6 +9431,30 @@
           </a:p>
         </p:txBody>
       </p:sp>
+      <p:pic>
+        <p:nvPicPr>
+          <p:cNvPr id="71" name="Picture 70" descr="architecture.png"/>
+          <p:cNvPicPr>
+            <a:picLocks noChangeAspect="1"/>
+          </p:cNvPicPr>
+          <p:nvPr/>
+        </p:nvPicPr>
+        <p:blipFill>
+          <a:blip r:embed="rId3"/>
+          <a:stretch>
+            <a:fillRect/>
+          </a:stretch>
+        </p:blipFill>
+        <p:spPr>
+          <a:xfrm>
+            <a:off x="4578512" y="696595"/>
+            <a:ext cx="1490655" cy="2070100"/>
+          </a:xfrm>
+          <a:prstGeom prst="rect">
+            <a:avLst/>
+          </a:prstGeom>
+        </p:spPr>
+      </p:pic>
     </p:spTree>
     <p:extLst>
       <p:ext uri="{BB962C8B-B14F-4D97-AF65-F5344CB8AC3E}">
@@ -12138,7 +12210,7 @@
           <a:noFill/>
         </p:spPr>
         <p:txBody>
-          <a:bodyPr wrap="square" lIns="0" rIns="0" tIns="0" bIns="0">
+          <a:bodyPr wrap="square" lIns="0" tIns="0" rIns="0" bIns="0">
             <a:spAutoFit/>
           </a:bodyPr>
           <a:lstStyle/>
@@ -12197,7 +12269,7 @@
           <a:noFill/>
         </p:spPr>
         <p:txBody>
-          <a:bodyPr wrap="square" lIns="0" rIns="0" tIns="0" bIns="0">
+          <a:bodyPr wrap="square" lIns="0" tIns="0" rIns="0" bIns="0">
             <a:spAutoFit/>
           </a:bodyPr>
           <a:lstStyle/>
@@ -12256,7 +12328,7 @@
           <a:noFill/>
         </p:spPr>
         <p:txBody>
-          <a:bodyPr wrap="square" lIns="0" rIns="0" tIns="0" bIns="0">
+          <a:bodyPr wrap="square" lIns="0" tIns="0" rIns="0" bIns="0">
             <a:spAutoFit/>
           </a:bodyPr>
           <a:lstStyle/>
@@ -12315,7 +12387,7 @@
           <a:noFill/>
         </p:spPr>
         <p:txBody>
-          <a:bodyPr wrap="square" lIns="0" rIns="0" tIns="0" bIns="0">
+          <a:bodyPr wrap="square" lIns="0" tIns="0" rIns="0" bIns="0">
             <a:spAutoFit/>
           </a:bodyPr>
           <a:lstStyle/>
@@ -12374,7 +12446,7 @@
           <a:noFill/>
         </p:spPr>
         <p:txBody>
-          <a:bodyPr wrap="square" lIns="0" rIns="0" tIns="0" bIns="0">
+          <a:bodyPr wrap="square" lIns="0" tIns="0" rIns="0" bIns="0">
             <a:spAutoFit/>
           </a:bodyPr>
           <a:lstStyle/>
@@ -12433,7 +12505,7 @@
           <a:noFill/>
         </p:spPr>
         <p:txBody>
-          <a:bodyPr wrap="square" lIns="0" rIns="0" tIns="0" bIns="0">
+          <a:bodyPr wrap="square" lIns="0" tIns="0" rIns="0" bIns="0">
             <a:spAutoFit/>
           </a:bodyPr>
           <a:lstStyle/>
@@ -12475,6 +12547,30 @@
           </a:p>
         </p:txBody>
       </p:sp>
+      <p:pic>
+        <p:nvPicPr>
+          <p:cNvPr id="71" name="Picture 70" descr="aegis_hook_analogy.png"/>
+          <p:cNvPicPr>
+            <a:picLocks noChangeAspect="1"/>
+          </p:cNvPicPr>
+          <p:nvPr/>
+        </p:nvPicPr>
+        <p:blipFill>
+          <a:blip r:embed="rId3"/>
+          <a:stretch>
+            <a:fillRect/>
+          </a:stretch>
+        </p:blipFill>
+        <p:spPr>
+          <a:xfrm>
+            <a:off x="3729990" y="1369717"/>
+            <a:ext cx="3187700" cy="723856"/>
+          </a:xfrm>
+          <a:prstGeom prst="rect">
+            <a:avLst/>
+          </a:prstGeom>
+        </p:spPr>
+      </p:pic>
     </p:spTree>
     <p:extLst>
       <p:ext uri="{BB962C8B-B14F-4D97-AF65-F5344CB8AC3E}">
@@ -15235,7 +15331,7 @@
           <a:noFill/>
         </p:spPr>
         <p:txBody>
-          <a:bodyPr wrap="square" lIns="0" rIns="0" tIns="0" bIns="0">
+          <a:bodyPr wrap="square" lIns="0" tIns="0" rIns="0" bIns="0">
             <a:spAutoFit/>
           </a:bodyPr>
           <a:lstStyle/>
@@ -15294,7 +15390,7 @@
           <a:noFill/>
         </p:spPr>
         <p:txBody>
-          <a:bodyPr wrap="square" lIns="0" rIns="0" tIns="0" bIns="0">
+          <a:bodyPr wrap="square" lIns="0" tIns="0" rIns="0" bIns="0">
             <a:spAutoFit/>
           </a:bodyPr>
           <a:lstStyle/>
@@ -15353,7 +15449,7 @@
           <a:noFill/>
         </p:spPr>
         <p:txBody>
-          <a:bodyPr wrap="square" lIns="0" rIns="0" tIns="0" bIns="0">
+          <a:bodyPr wrap="square" lIns="0" tIns="0" rIns="0" bIns="0">
             <a:spAutoFit/>
           </a:bodyPr>
           <a:lstStyle/>
@@ -15412,7 +15508,7 @@
           <a:noFill/>
         </p:spPr>
         <p:txBody>
-          <a:bodyPr wrap="square" lIns="0" rIns="0" tIns="0" bIns="0">
+          <a:bodyPr wrap="square" lIns="0" tIns="0" rIns="0" bIns="0">
             <a:spAutoFit/>
           </a:bodyPr>
           <a:lstStyle/>
@@ -15471,7 +15567,7 @@
           <a:noFill/>
         </p:spPr>
         <p:txBody>
-          <a:bodyPr wrap="square" lIns="0" rIns="0" tIns="0" bIns="0">
+          <a:bodyPr wrap="square" lIns="0" tIns="0" rIns="0" bIns="0">
             <a:spAutoFit/>
           </a:bodyPr>
           <a:lstStyle/>
@@ -15530,7 +15626,7 @@
           <a:noFill/>
         </p:spPr>
         <p:txBody>
-          <a:bodyPr wrap="square" lIns="0" rIns="0" tIns="0" bIns="0">
+          <a:bodyPr wrap="square" lIns="0" tIns="0" rIns="0" bIns="0">
             <a:spAutoFit/>
           </a:bodyPr>
           <a:lstStyle/>
@@ -15572,6 +15668,30 @@
           </a:p>
         </p:txBody>
       </p:sp>
+      <p:pic>
+        <p:nvPicPr>
+          <p:cNvPr id="71" name="Picture 70" descr="architecture.png"/>
+          <p:cNvPicPr>
+            <a:picLocks noChangeAspect="1"/>
+          </p:cNvPicPr>
+          <p:nvPr/>
+        </p:nvPicPr>
+        <p:blipFill>
+          <a:blip r:embed="rId3"/>
+          <a:stretch>
+            <a:fillRect/>
+          </a:stretch>
+        </p:blipFill>
+        <p:spPr>
+          <a:xfrm>
+            <a:off x="1086012" y="696595"/>
+            <a:ext cx="1490655" cy="2070100"/>
+          </a:xfrm>
+          <a:prstGeom prst="rect">
+            <a:avLst/>
+          </a:prstGeom>
+        </p:spPr>
+      </p:pic>
     </p:spTree>
     <p:extLst>
       <p:ext uri="{BB962C8B-B14F-4D97-AF65-F5344CB8AC3E}">
@@ -18319,7 +18439,7 @@
           <a:noFill/>
         </p:spPr>
         <p:txBody>
-          <a:bodyPr wrap="square" lIns="0" rIns="0" tIns="0" bIns="0">
+          <a:bodyPr wrap="square" lIns="0" tIns="0" rIns="0" bIns="0">
             <a:spAutoFit/>
           </a:bodyPr>
           <a:lstStyle/>
@@ -18378,7 +18498,7 @@
           <a:noFill/>
         </p:spPr>
         <p:txBody>
-          <a:bodyPr wrap="square" lIns="0" rIns="0" tIns="0" bIns="0">
+          <a:bodyPr wrap="square" lIns="0" tIns="0" rIns="0" bIns="0">
             <a:spAutoFit/>
           </a:bodyPr>
           <a:lstStyle/>
@@ -18437,7 +18557,7 @@
           <a:noFill/>
         </p:spPr>
         <p:txBody>
-          <a:bodyPr wrap="square" lIns="0" rIns="0" tIns="0" bIns="0">
+          <a:bodyPr wrap="square" lIns="0" tIns="0" rIns="0" bIns="0">
             <a:spAutoFit/>
           </a:bodyPr>
           <a:lstStyle/>
@@ -18496,7 +18616,7 @@
           <a:noFill/>
         </p:spPr>
         <p:txBody>
-          <a:bodyPr wrap="square" lIns="0" rIns="0" tIns="0" bIns="0">
+          <a:bodyPr wrap="square" lIns="0" tIns="0" rIns="0" bIns="0">
             <a:spAutoFit/>
           </a:bodyPr>
           <a:lstStyle/>
@@ -18555,7 +18675,7 @@
           <a:noFill/>
         </p:spPr>
         <p:txBody>
-          <a:bodyPr wrap="square" lIns="0" rIns="0" tIns="0" bIns="0">
+          <a:bodyPr wrap="square" lIns="0" tIns="0" rIns="0" bIns="0">
             <a:spAutoFit/>
           </a:bodyPr>
           <a:lstStyle/>
@@ -18614,7 +18734,7 @@
           <a:noFill/>
         </p:spPr>
         <p:txBody>
-          <a:bodyPr wrap="square" lIns="0" rIns="0" tIns="0" bIns="0">
+          <a:bodyPr wrap="square" lIns="0" tIns="0" rIns="0" bIns="0">
             <a:spAutoFit/>
           </a:bodyPr>
           <a:lstStyle/>
@@ -18656,6 +18776,54 @@
           </a:p>
         </p:txBody>
       </p:sp>
+      <p:pic>
+        <p:nvPicPr>
+          <p:cNvPr id="71" name="Picture 70" descr="dashboard.jpg"/>
+          <p:cNvPicPr>
+            <a:picLocks noChangeAspect="1"/>
+          </p:cNvPicPr>
+          <p:nvPr/>
+        </p:nvPicPr>
+        <p:blipFill>
+          <a:blip r:embed="rId3"/>
+          <a:stretch>
+            <a:fillRect/>
+          </a:stretch>
+        </p:blipFill>
+        <p:spPr>
+          <a:xfrm>
+            <a:off x="340868" y="696595"/>
+            <a:ext cx="2980944" cy="2070100"/>
+          </a:xfrm>
+          <a:prstGeom prst="rect">
+            <a:avLst/>
+          </a:prstGeom>
+        </p:spPr>
+      </p:pic>
+      <p:pic>
+        <p:nvPicPr>
+          <p:cNvPr id="72" name="Picture 71" descr="aegis_eval.png"/>
+          <p:cNvPicPr>
+            <a:picLocks noChangeAspect="1"/>
+          </p:cNvPicPr>
+          <p:nvPr/>
+        </p:nvPicPr>
+        <p:blipFill>
+          <a:blip r:embed="rId4"/>
+          <a:stretch>
+            <a:fillRect/>
+          </a:stretch>
+        </p:blipFill>
+        <p:spPr>
+          <a:xfrm>
+            <a:off x="7235190" y="4361584"/>
+            <a:ext cx="3187700" cy="1217121"/>
+          </a:xfrm>
+          <a:prstGeom prst="rect">
+            <a:avLst/>
+          </a:prstGeom>
+        </p:spPr>
+      </p:pic>
     </p:spTree>
     <p:extLst>
       <p:ext uri="{BB962C8B-B14F-4D97-AF65-F5344CB8AC3E}">
@@ -21382,7 +21550,7 @@
           <a:noFill/>
         </p:spPr>
         <p:txBody>
-          <a:bodyPr wrap="square" lIns="0" rIns="0" tIns="0" bIns="0">
+          <a:bodyPr wrap="square" lIns="0" tIns="0" rIns="0" bIns="0">
             <a:spAutoFit/>
           </a:bodyPr>
           <a:lstStyle/>
@@ -21441,7 +21609,7 @@
           <a:noFill/>
         </p:spPr>
         <p:txBody>
-          <a:bodyPr wrap="square" lIns="0" rIns="0" tIns="0" bIns="0">
+          <a:bodyPr wrap="square" lIns="0" tIns="0" rIns="0" bIns="0">
             <a:spAutoFit/>
           </a:bodyPr>
           <a:lstStyle/>
@@ -21500,7 +21668,7 @@
           <a:noFill/>
         </p:spPr>
         <p:txBody>
-          <a:bodyPr wrap="square" lIns="0" rIns="0" tIns="0" bIns="0">
+          <a:bodyPr wrap="square" lIns="0" tIns="0" rIns="0" bIns="0">
             <a:spAutoFit/>
           </a:bodyPr>
           <a:lstStyle/>
@@ -21559,7 +21727,7 @@
           <a:noFill/>
         </p:spPr>
         <p:txBody>
-          <a:bodyPr wrap="square" lIns="0" rIns="0" tIns="0" bIns="0">
+          <a:bodyPr wrap="square" lIns="0" tIns="0" rIns="0" bIns="0">
             <a:spAutoFit/>
           </a:bodyPr>
           <a:lstStyle/>
@@ -21618,7 +21786,7 @@
           <a:noFill/>
         </p:spPr>
         <p:txBody>
-          <a:bodyPr wrap="square" lIns="0" rIns="0" tIns="0" bIns="0">
+          <a:bodyPr wrap="square" lIns="0" tIns="0" rIns="0" bIns="0">
             <a:spAutoFit/>
           </a:bodyPr>
           <a:lstStyle/>
@@ -21677,7 +21845,7 @@
           <a:noFill/>
         </p:spPr>
         <p:txBody>
-          <a:bodyPr wrap="square" lIns="0" rIns="0" tIns="0" bIns="0">
+          <a:bodyPr wrap="square" lIns="0" tIns="0" rIns="0" bIns="0">
             <a:spAutoFit/>
           </a:bodyPr>
           <a:lstStyle/>
@@ -21719,6 +21887,30 @@
           </a:p>
         </p:txBody>
       </p:sp>
+      <p:pic>
+        <p:nvPicPr>
+          <p:cNvPr id="71" name="Picture 70" descr="aegis_eval.png"/>
+          <p:cNvPicPr>
+            <a:picLocks noChangeAspect="1"/>
+          </p:cNvPicPr>
+          <p:nvPr/>
+        </p:nvPicPr>
+        <p:blipFill>
+          <a:blip r:embed="rId3"/>
+          <a:stretch>
+            <a:fillRect/>
+          </a:stretch>
+        </p:blipFill>
+        <p:spPr>
+          <a:xfrm>
+            <a:off x="7235190" y="4361584"/>
+            <a:ext cx="3187700" cy="1217121"/>
+          </a:xfrm>
+          <a:prstGeom prst="rect">
+            <a:avLst/>
+          </a:prstGeom>
+        </p:spPr>
+      </p:pic>
     </p:spTree>
     <p:extLst>
       <p:ext uri="{BB962C8B-B14F-4D97-AF65-F5344CB8AC3E}">
@@ -24525,7 +24717,7 @@
           <a:noFill/>
         </p:spPr>
         <p:txBody>
-          <a:bodyPr wrap="square" lIns="0" rIns="0" tIns="0" bIns="0">
+          <a:bodyPr wrap="square" lIns="0" tIns="0" rIns="0" bIns="0">
             <a:spAutoFit/>
           </a:bodyPr>
           <a:lstStyle/>
@@ -24584,7 +24776,7 @@
           <a:noFill/>
         </p:spPr>
         <p:txBody>
-          <a:bodyPr wrap="square" lIns="0" rIns="0" tIns="0" bIns="0">
+          <a:bodyPr wrap="square" lIns="0" tIns="0" rIns="0" bIns="0">
             <a:spAutoFit/>
           </a:bodyPr>
           <a:lstStyle/>
@@ -24643,7 +24835,7 @@
           <a:noFill/>
         </p:spPr>
         <p:txBody>
-          <a:bodyPr wrap="square" lIns="0" rIns="0" tIns="0" bIns="0">
+          <a:bodyPr wrap="square" lIns="0" tIns="0" rIns="0" bIns="0">
             <a:spAutoFit/>
           </a:bodyPr>
           <a:lstStyle/>
@@ -24702,7 +24894,7 @@
           <a:noFill/>
         </p:spPr>
         <p:txBody>
-          <a:bodyPr wrap="square" lIns="0" rIns="0" tIns="0" bIns="0">
+          <a:bodyPr wrap="square" lIns="0" tIns="0" rIns="0" bIns="0">
             <a:spAutoFit/>
           </a:bodyPr>
           <a:lstStyle/>
@@ -24749,7 +24941,7 @@
           <a:noFill/>
         </p:spPr>
         <p:txBody>
-          <a:bodyPr wrap="square" lIns="0" rIns="0" tIns="0" bIns="0">
+          <a:bodyPr wrap="square" lIns="0" tIns="0" rIns="0" bIns="0">
             <a:spAutoFit/>
           </a:bodyPr>
           <a:lstStyle/>
@@ -24808,7 +25000,7 @@
           <a:noFill/>
         </p:spPr>
         <p:txBody>
-          <a:bodyPr wrap="square" lIns="0" rIns="0" tIns="0" bIns="0">
+          <a:bodyPr wrap="square" lIns="0" tIns="0" rIns="0" bIns="0">
             <a:spAutoFit/>
           </a:bodyPr>
           <a:lstStyle/>
@@ -27589,7 +27781,7 @@
           <a:noFill/>
         </p:spPr>
         <p:txBody>
-          <a:bodyPr wrap="square" lIns="0" rIns="0" tIns="0" bIns="0">
+          <a:bodyPr wrap="square" lIns="0" tIns="0" rIns="0" bIns="0">
             <a:spAutoFit/>
           </a:bodyPr>
           <a:lstStyle/>
@@ -27648,7 +27840,7 @@
           <a:noFill/>
         </p:spPr>
         <p:txBody>
-          <a:bodyPr wrap="square" lIns="0" rIns="0" tIns="0" bIns="0">
+          <a:bodyPr wrap="square" lIns="0" tIns="0" rIns="0" bIns="0">
             <a:spAutoFit/>
           </a:bodyPr>
           <a:lstStyle/>
@@ -27707,7 +27899,7 @@
           <a:noFill/>
         </p:spPr>
         <p:txBody>
-          <a:bodyPr wrap="square" lIns="0" rIns="0" tIns="0" bIns="0">
+          <a:bodyPr wrap="square" lIns="0" tIns="0" rIns="0" bIns="0">
             <a:spAutoFit/>
           </a:bodyPr>
           <a:lstStyle/>
@@ -27766,7 +27958,7 @@
           <a:noFill/>
         </p:spPr>
         <p:txBody>
-          <a:bodyPr wrap="square" lIns="0" rIns="0" tIns="0" bIns="0">
+          <a:bodyPr wrap="square" lIns="0" tIns="0" rIns="0" bIns="0">
             <a:spAutoFit/>
           </a:bodyPr>
           <a:lstStyle/>
@@ -27825,7 +28017,7 @@
           <a:noFill/>
         </p:spPr>
         <p:txBody>
-          <a:bodyPr wrap="square" lIns="0" rIns="0" tIns="0" bIns="0">
+          <a:bodyPr wrap="square" lIns="0" tIns="0" rIns="0" bIns="0">
             <a:spAutoFit/>
           </a:bodyPr>
           <a:lstStyle/>
@@ -27884,7 +28076,7 @@
           <a:noFill/>
         </p:spPr>
         <p:txBody>
-          <a:bodyPr wrap="square" lIns="0" rIns="0" tIns="0" bIns="0">
+          <a:bodyPr wrap="square" lIns="0" tIns="0" rIns="0" bIns="0">
             <a:spAutoFit/>
           </a:bodyPr>
           <a:lstStyle/>
@@ -27958,10 +28150,10 @@
       </p:grpSpPr>
       <p:sp>
         <p:nvSpPr>
-          <p:cNvPr id="30" name="Google Shape;749;p69">
+          <p:cNvPr id="28" name="Google Shape;749;p69">
             <a:extLst>
               <a:ext uri="{FF2B5EF4-FFF2-40B4-BE49-F238E27FC236}">
-                <a16:creationId xmlns:a16="http://schemas.microsoft.com/office/drawing/2014/main" id="{20E7ABEA-04E4-4B5E-8EB6-B692BCF28DBF}"/>
+                <a16:creationId xmlns:a16="http://schemas.microsoft.com/office/drawing/2014/main" id="{CBD30F07-6871-4503-B70C-03DD4C50FDD9}"/>
               </a:ext>
             </a:extLst>
           </p:cNvPr>
@@ -27970,7 +28162,7 @@
         </p:nvSpPr>
         <p:spPr>
           <a:xfrm>
-            <a:off x="1196569" y="5053383"/>
+            <a:off x="5344319" y="2194328"/>
             <a:ext cx="2384955" cy="2392056"/>
           </a:xfrm>
           <a:prstGeom prst="ellipse">
@@ -27997,10 +28189,10 @@
       </p:sp>
       <p:sp>
         <p:nvSpPr>
-          <p:cNvPr id="29" name="Google Shape;749;p69">
+          <p:cNvPr id="27" name="Google Shape;749;p69">
             <a:extLst>
               <a:ext uri="{FF2B5EF4-FFF2-40B4-BE49-F238E27FC236}">
-                <a16:creationId xmlns:a16="http://schemas.microsoft.com/office/drawing/2014/main" id="{A06EF363-7321-4789-B70A-BF7EE0475D79}"/>
+                <a16:creationId xmlns:a16="http://schemas.microsoft.com/office/drawing/2014/main" id="{BCB06B9F-0035-4EAD-B976-4A1DE9730F61}"/>
               </a:ext>
             </a:extLst>
           </p:cNvPr>
@@ -28009,7 +28201,7 @@
         </p:nvSpPr>
         <p:spPr>
           <a:xfrm>
-            <a:off x="4197868" y="216894"/>
+            <a:off x="1196569" y="2122577"/>
             <a:ext cx="2384955" cy="2392056"/>
           </a:xfrm>
           <a:prstGeom prst="ellipse">
@@ -28030,124 +28222,7 @@
           </a:bodyPr>
           <a:lstStyle/>
           <a:p>
-            <a:endParaRPr sz="1578"/>
-          </a:p>
-        </p:txBody>
-      </p:sp>
-      <p:sp>
-        <p:nvSpPr>
-          <p:cNvPr id="28" name="Google Shape;749;p69">
-            <a:extLst>
-              <a:ext uri="{FF2B5EF4-FFF2-40B4-BE49-F238E27FC236}">
-                <a16:creationId xmlns:a16="http://schemas.microsoft.com/office/drawing/2014/main" id="{CBD30F07-6871-4503-B70C-03DD4C50FDD9}"/>
-              </a:ext>
-            </a:extLst>
-          </p:cNvPr>
-          <p:cNvSpPr/>
-          <p:nvPr/>
-        </p:nvSpPr>
-        <p:spPr>
-          <a:xfrm>
-            <a:off x="5262846" y="5170794"/>
-            <a:ext cx="2384955" cy="2392056"/>
-          </a:xfrm>
-          <a:prstGeom prst="ellipse">
-            <a:avLst/>
-          </a:prstGeom>
-          <a:solidFill>
-            <a:srgbClr val="B6CFE6">
-              <a:alpha val="35750"/>
-            </a:srgbClr>
-          </a:solidFill>
-          <a:ln>
-            <a:noFill/>
-          </a:ln>
-        </p:spPr>
-        <p:txBody>
-          <a:bodyPr spcFirstLastPara="1" wrap="square" lIns="80152" tIns="80152" rIns="80152" bIns="80152" anchor="ctr" anchorCtr="0">
-            <a:noAutofit/>
-          </a:bodyPr>
-          <a:lstStyle/>
-          <a:p>
-            <a:endParaRPr sz="1578"/>
-          </a:p>
-        </p:txBody>
-      </p:sp>
-      <p:sp>
-        <p:nvSpPr>
-          <p:cNvPr id="27" name="Google Shape;749;p69">
-            <a:extLst>
-              <a:ext uri="{FF2B5EF4-FFF2-40B4-BE49-F238E27FC236}">
-                <a16:creationId xmlns:a16="http://schemas.microsoft.com/office/drawing/2014/main" id="{BCB06B9F-0035-4EAD-B976-4A1DE9730F61}"/>
-              </a:ext>
-            </a:extLst>
-          </p:cNvPr>
-          <p:cNvSpPr/>
-          <p:nvPr/>
-        </p:nvSpPr>
-        <p:spPr>
-          <a:xfrm>
-            <a:off x="1196569" y="2122577"/>
-            <a:ext cx="2384955" cy="2392056"/>
-          </a:xfrm>
-          <a:prstGeom prst="ellipse">
-            <a:avLst/>
-          </a:prstGeom>
-          <a:solidFill>
-            <a:srgbClr val="B6CFE6">
-              <a:alpha val="35750"/>
-            </a:srgbClr>
-          </a:solidFill>
-          <a:ln>
-            <a:noFill/>
-          </a:ln>
-        </p:spPr>
-        <p:txBody>
-          <a:bodyPr spcFirstLastPara="1" wrap="square" lIns="80152" tIns="80152" rIns="80152" bIns="80152" anchor="ctr" anchorCtr="0">
-            <a:noAutofit/>
-          </a:bodyPr>
-          <a:lstStyle/>
-          <a:p>
             <a:endParaRPr sz="1578" dirty="0"/>
-          </a:p>
-        </p:txBody>
-      </p:sp>
-      <p:sp>
-        <p:nvSpPr>
-          <p:cNvPr id="23" name="Google Shape;749;p69">
-            <a:extLst>
-              <a:ext uri="{FF2B5EF4-FFF2-40B4-BE49-F238E27FC236}">
-                <a16:creationId xmlns:a16="http://schemas.microsoft.com/office/drawing/2014/main" id="{29D87DB6-7A6D-4180-8EA7-2E4C6B658563}"/>
-              </a:ext>
-            </a:extLst>
-          </p:cNvPr>
-          <p:cNvSpPr/>
-          <p:nvPr/>
-        </p:nvSpPr>
-        <p:spPr>
-          <a:xfrm>
-            <a:off x="7493931" y="2492500"/>
-            <a:ext cx="2384955" cy="2392056"/>
-          </a:xfrm>
-          <a:prstGeom prst="ellipse">
-            <a:avLst/>
-          </a:prstGeom>
-          <a:solidFill>
-            <a:srgbClr val="B6CFE6">
-              <a:alpha val="35750"/>
-            </a:srgbClr>
-          </a:solidFill>
-          <a:ln>
-            <a:noFill/>
-          </a:ln>
-        </p:spPr>
-        <p:txBody>
-          <a:bodyPr spcFirstLastPara="1" wrap="square" lIns="80152" tIns="80152" rIns="80152" bIns="80152" anchor="ctr" anchorCtr="0">
-            <a:noAutofit/>
-          </a:bodyPr>
-          <a:lstStyle/>
-          <a:p>
-            <a:endParaRPr sz="1578"/>
           </a:p>
         </p:txBody>
       </p:sp>
@@ -28169,7 +28244,7 @@
         </p:nvSpPr>
         <p:spPr>
           <a:xfrm>
-            <a:off x="482938" y="775246"/>
+            <a:off x="398963" y="658858"/>
             <a:ext cx="4861381" cy="968658"/>
           </a:xfrm>
         </p:spPr>
@@ -28389,7 +28464,7 @@
           </a:lstStyle>
           <a:p>
             <a:r>
-              <a:rPr lang="en-US" sz="1929"/>
+              <a:rPr lang="en-US" sz="1929" dirty="0"/>
               <a:t>Meet the team</a:t>
             </a:r>
           </a:p>
@@ -28403,8 +28478,8 @@
         </p:nvSpPr>
         <p:spPr>
           <a:xfrm>
-            <a:off x="600000" y="2800000"/>
-            <a:ext cx="9000000" cy="2000000"/>
+            <a:off x="1196568" y="3112699"/>
+            <a:ext cx="2384955" cy="400110"/>
           </a:xfrm>
           <a:prstGeom prst="rect">
             <a:avLst/>
@@ -28418,7 +28493,7 @@
           <a:lstStyle/>
           <a:p>
             <a:r>
-              <a:rPr sz="2000">
+              <a:rPr sz="2000" dirty="0">
                 <a:solidFill>
                   <a:srgbClr val="020C31"/>
                 </a:solidFill>
@@ -28427,16 +28502,55 @@
               <a:t>Fauzan Ejaz (Captain)</a:t>
             </a:r>
           </a:p>
-          <a:p>
-            <a:r>
-              <a:rPr sz="2000">
+        </p:txBody>
+      </p:sp>
+      <p:sp>
+        <p:nvSpPr>
+          <p:cNvPr id="2" name="TextBox 1">
+            <a:extLst>
+              <a:ext uri="{FF2B5EF4-FFF2-40B4-BE49-F238E27FC236}">
+                <a16:creationId xmlns:a16="http://schemas.microsoft.com/office/drawing/2014/main" id="{CE607F4C-6C97-4729-0B02-CAFD6CD56FDC}"/>
+              </a:ext>
+            </a:extLst>
+          </p:cNvPr>
+          <p:cNvSpPr txBox="1"/>
+          <p:nvPr/>
+        </p:nvSpPr>
+        <p:spPr>
+          <a:xfrm>
+            <a:off x="5682343" y="3099727"/>
+            <a:ext cx="2649894" cy="738664"/>
+          </a:xfrm>
+          <a:prstGeom prst="rect">
+            <a:avLst/>
+          </a:prstGeom>
+          <a:noFill/>
+        </p:spPr>
+        <p:txBody>
+          <a:bodyPr wrap="square" rtlCol="0">
+            <a:spAutoFit/>
+          </a:bodyPr>
+          <a:lstStyle/>
+          <a:p>
+            <a:r>
+              <a:rPr lang="en-IN" sz="2400" dirty="0" err="1">
                 <a:solidFill>
                   <a:srgbClr val="020C31"/>
                 </a:solidFill>
-                <a:latin typeface="Calibri"/>
-              </a:rPr>
-              <a:t>Llagami Tedi</a:t>
-            </a:r>
+              </a:rPr>
+              <a:t>Llagami</a:t>
+            </a:r>
+            <a:r>
+              <a:rPr lang="en-IN" sz="2400" dirty="0">
+                <a:solidFill>
+                  <a:srgbClr val="020C31"/>
+                </a:solidFill>
+              </a:rPr>
+              <a:t> Tedi</a:t>
+            </a:r>
+          </a:p>
+          <a:p>
+            <a:endParaRPr lang="en-IN" dirty="0"/>
           </a:p>
         </p:txBody>
       </p:sp>
@@ -28944,7 +29058,22 @@
 </file>
 
 <file path=customXml/itemProps2.xml><?xml version="1.0" encoding="utf-8"?>
-<ds:datastoreItem xmlns:ds="http://schemas.openxmlformats.org/officeDocument/2006/customXml" ds:itemID="{AFE32100-327A-46D5-A299-81E97F5FBF53}"/>
+<ds:datastoreItem xmlns:ds="http://schemas.openxmlformats.org/officeDocument/2006/customXml" ds:itemID="{AFE32100-327A-46D5-A299-81E97F5FBF53}">
+  <ds:schemaRefs>
+    <ds:schemaRef ds:uri="http://schemas.microsoft.com/office/2006/metadata/contentType"/>
+    <ds:schemaRef ds:uri="http://schemas.microsoft.com/office/2006/metadata/properties/metaAttributes"/>
+    <ds:schemaRef ds:uri="http://www.w3.org/2001/XMLSchema"/>
+    <ds:schemaRef ds:uri="http://schemas.microsoft.com/office/2006/metadata/properties"/>
+    <ds:schemaRef ds:uri="df1bf422-076b-4923-a343-86f92e681c13"/>
+    <ds:schemaRef ds:uri="17320c4f-b4d7-4a2f-a568-c234bef09358"/>
+    <ds:schemaRef ds:uri="http://schemas.microsoft.com/office/2006/documentManagement/types"/>
+    <ds:schemaRef ds:uri="http://schemas.microsoft.com/office/infopath/2007/PartnerControls"/>
+    <ds:schemaRef ds:uri="http://schemas.openxmlformats.org/package/2006/metadata/core-properties"/>
+    <ds:schemaRef ds:uri="http://purl.org/dc/elements/1.1/"/>
+    <ds:schemaRef ds:uri="http://purl.org/dc/terms/"/>
+    <ds:schemaRef ds:uri="http://schemas.microsoft.com/internal/obd"/>
+  </ds:schemaRefs>
+</ds:datastoreItem>
 </file>
 
 <file path=customXml/itemProps3.xml><?xml version="1.0" encoding="utf-8"?>

</xml_diff>

<commit_message>
Insert real screenshots into the storyboard: live dashboard + real Open5GS log
Adds real captured images to the storyboard panels that previously only
had text captions: three live screenshots of the actual AEGIS dashboard
(live attack injection before/after, incident inspector, network
topology - captured via a background agent driving a real browser
session against the live app), and a clean rendering of a real
UERANSIM UE registration log captured against the real Open5GS core
(the terminal itself isn't screen-recordable in this environment, so
the real log text is rendered as a graphic rather than fabricated).

11 real images now placed across pages 1-6. Page 9 (team slide,
already fixed manually) is untouched, verified before and after.

Also commits the videomaker cover note drafted earlier (reuse-vs-new
breakdown for the briefing meeting).
</commit_message>
<xml_diff>
--- a/slides/GATE-3/AEGIS_Gate3_Storyboard.pptx
+++ b/slides/GATE-3/AEGIS_Gate3_Storyboard.pptx
@@ -5799,62 +5799,6 @@
       </p:sp>
       <p:sp>
         <p:nvSpPr>
-          <p:cNvPr id="63" name="object 6">
-            <a:extLst>
-              <a:ext uri="{FF2B5EF4-FFF2-40B4-BE49-F238E27FC236}">
-                <a16:creationId xmlns:a16="http://schemas.microsoft.com/office/drawing/2014/main" id="{A92A90AF-5BC5-164C-BAE0-15271A672BC8}"/>
-              </a:ext>
-            </a:extLst>
-          </p:cNvPr>
-          <p:cNvSpPr txBox="1"/>
-          <p:nvPr/>
-        </p:nvSpPr>
-        <p:spPr>
-          <a:xfrm>
-            <a:off x="73342" y="100951"/>
-            <a:ext cx="328295" cy="187325"/>
-          </a:xfrm>
-          <a:prstGeom prst="rect">
-            <a:avLst/>
-          </a:prstGeom>
-        </p:spPr>
-        <p:txBody>
-          <a:bodyPr vert="horz" wrap="square" lIns="0" tIns="12700" rIns="0" bIns="0" rtlCol="0">
-            <a:spAutoFit/>
-          </a:bodyPr>
-          <a:lstStyle/>
-          <a:p>
-            <a:pPr marL="0" marR="0">
-              <a:spcBef>
-                <a:spcPts val="100"/>
-              </a:spcBef>
-              <a:spcAft>
-                <a:spcPts val="0"/>
-              </a:spcAft>
-            </a:pPr>
-            <a:r>
-              <a:rPr lang="en-US" sz="1100" kern="1200" spc="-40" dirty="0">
-                <a:solidFill>
-                  <a:srgbClr val="9B9B9B"/>
-                </a:solidFill>
-                <a:effectLst/>
-                <a:latin typeface="Arial" panose="020B0604020202020204" pitchFamily="34" charset="0"/>
-                <a:ea typeface="Times New Roman" panose="02020603050405020304" pitchFamily="18" charset="0"/>
-                <a:cs typeface="Arial" panose="020B0604020202020204" pitchFamily="34" charset="0"/>
-              </a:rPr>
-              <a:t>Title: AEGIS - Zero-Trust Identity for AI Agents</a:t>
-            </a:r>
-            <a:endParaRPr lang="en-US" sz="1100" dirty="0">
-              <a:effectLst/>
-              <a:latin typeface="Arial" panose="020B0604020202020204" pitchFamily="34" charset="0"/>
-              <a:ea typeface="Times New Roman" panose="02020603050405020304" pitchFamily="18" charset="0"/>
-              <a:cs typeface="Arial" panose="020B0604020202020204" pitchFamily="34" charset="0"/>
-            </a:endParaRPr>
-          </a:p>
-        </p:txBody>
-      </p:sp>
-      <p:sp>
-        <p:nvSpPr>
           <p:cNvPr id="64" name="object 5">
             <a:extLst>
               <a:ext uri="{FF2B5EF4-FFF2-40B4-BE49-F238E27FC236}">
@@ -6347,8 +6291,8 @@
           </a:stretch>
         </p:blipFill>
         <p:spPr>
-          <a:xfrm>
-            <a:off x="8083712" y="696595"/>
+          <a:xfrm rot="16200000">
+            <a:off x="8083712" y="818673"/>
             <a:ext cx="1490655" cy="2070100"/>
           </a:xfrm>
           <a:prstGeom prst="rect">
@@ -6372,8 +6316,8 @@
         </p:blipFill>
         <p:spPr>
           <a:xfrm>
-            <a:off x="237490" y="4608217"/>
-            <a:ext cx="3187700" cy="723856"/>
+            <a:off x="319563" y="4619083"/>
+            <a:ext cx="3023553" cy="723856"/>
           </a:xfrm>
           <a:prstGeom prst="rect">
             <a:avLst/>
@@ -8979,62 +8923,6 @@
       </p:sp>
       <p:sp>
         <p:nvSpPr>
-          <p:cNvPr id="63" name="object 6">
-            <a:extLst>
-              <a:ext uri="{FF2B5EF4-FFF2-40B4-BE49-F238E27FC236}">
-                <a16:creationId xmlns:a16="http://schemas.microsoft.com/office/drawing/2014/main" id="{A92A90AF-5BC5-164C-BAE0-15271A672BC8}"/>
-              </a:ext>
-            </a:extLst>
-          </p:cNvPr>
-          <p:cNvSpPr txBox="1"/>
-          <p:nvPr/>
-        </p:nvSpPr>
-        <p:spPr>
-          <a:xfrm>
-            <a:off x="365811" y="239475"/>
-            <a:ext cx="328295" cy="187325"/>
-          </a:xfrm>
-          <a:prstGeom prst="rect">
-            <a:avLst/>
-          </a:prstGeom>
-        </p:spPr>
-        <p:txBody>
-          <a:bodyPr vert="horz" wrap="square" lIns="0" tIns="12700" rIns="0" bIns="0" rtlCol="0">
-            <a:spAutoFit/>
-          </a:bodyPr>
-          <a:lstStyle/>
-          <a:p>
-            <a:pPr marL="0" marR="0">
-              <a:spcBef>
-                <a:spcPts val="100"/>
-              </a:spcBef>
-              <a:spcAft>
-                <a:spcPts val="0"/>
-              </a:spcAft>
-            </a:pPr>
-            <a:r>
-              <a:rPr lang="en-US" sz="1100" kern="1200" spc="-40">
-                <a:solidFill>
-                  <a:srgbClr val="9B9B9B"/>
-                </a:solidFill>
-                <a:effectLst/>
-                <a:latin typeface="Arial" panose="020B0604020202020204" pitchFamily="34" charset="0"/>
-                <a:ea typeface="Times New Roman" panose="02020603050405020304" pitchFamily="18" charset="0"/>
-                <a:cs typeface="Arial" panose="020B0604020202020204" pitchFamily="34" charset="0"/>
-              </a:rPr>
-              <a:t>Title: AEGIS - Zero-Trust Identity for AI Agents</a:t>
-            </a:r>
-            <a:endParaRPr lang="en-US" sz="1100">
-              <a:effectLst/>
-              <a:latin typeface="Arial" panose="020B0604020202020204" pitchFamily="34" charset="0"/>
-              <a:ea typeface="Times New Roman" panose="02020603050405020304" pitchFamily="18" charset="0"/>
-              <a:cs typeface="Arial" panose="020B0604020202020204" pitchFamily="34" charset="0"/>
-            </a:endParaRPr>
-          </a:p>
-        </p:txBody>
-      </p:sp>
-      <p:sp>
-        <p:nvSpPr>
           <p:cNvPr id="64" name="object 5">
             <a:extLst>
               <a:ext uri="{FF2B5EF4-FFF2-40B4-BE49-F238E27FC236}">
@@ -9446,8 +9334,8 @@
           </a:stretch>
         </p:blipFill>
         <p:spPr>
-          <a:xfrm>
-            <a:off x="4578512" y="696595"/>
+          <a:xfrm rot="16200000">
+            <a:off x="4572162" y="805819"/>
             <a:ext cx="1490655" cy="2070100"/>
           </a:xfrm>
           <a:prstGeom prst="rect">
@@ -12083,62 +11971,6 @@
       </p:sp>
       <p:sp>
         <p:nvSpPr>
-          <p:cNvPr id="63" name="object 6">
-            <a:extLst>
-              <a:ext uri="{FF2B5EF4-FFF2-40B4-BE49-F238E27FC236}">
-                <a16:creationId xmlns:a16="http://schemas.microsoft.com/office/drawing/2014/main" id="{A92A90AF-5BC5-164C-BAE0-15271A672BC8}"/>
-              </a:ext>
-            </a:extLst>
-          </p:cNvPr>
-          <p:cNvSpPr txBox="1"/>
-          <p:nvPr/>
-        </p:nvSpPr>
-        <p:spPr>
-          <a:xfrm>
-            <a:off x="365811" y="239475"/>
-            <a:ext cx="328295" cy="187325"/>
-          </a:xfrm>
-          <a:prstGeom prst="rect">
-            <a:avLst/>
-          </a:prstGeom>
-        </p:spPr>
-        <p:txBody>
-          <a:bodyPr vert="horz" wrap="square" lIns="0" tIns="12700" rIns="0" bIns="0" rtlCol="0">
-            <a:spAutoFit/>
-          </a:bodyPr>
-          <a:lstStyle/>
-          <a:p>
-            <a:pPr marL="0" marR="0">
-              <a:spcBef>
-                <a:spcPts val="100"/>
-              </a:spcBef>
-              <a:spcAft>
-                <a:spcPts val="0"/>
-              </a:spcAft>
-            </a:pPr>
-            <a:r>
-              <a:rPr lang="en-US" sz="1100" kern="1200" spc="-40">
-                <a:solidFill>
-                  <a:srgbClr val="9B9B9B"/>
-                </a:solidFill>
-                <a:effectLst/>
-                <a:latin typeface="Arial" panose="020B0604020202020204" pitchFamily="34" charset="0"/>
-                <a:ea typeface="Times New Roman" panose="02020603050405020304" pitchFamily="18" charset="0"/>
-                <a:cs typeface="Arial" panose="020B0604020202020204" pitchFamily="34" charset="0"/>
-              </a:rPr>
-              <a:t>Title: AEGIS - Zero-Trust Identity for AI Agents</a:t>
-            </a:r>
-            <a:endParaRPr lang="en-US" sz="1100">
-              <a:effectLst/>
-              <a:latin typeface="Arial" panose="020B0604020202020204" pitchFamily="34" charset="0"/>
-              <a:ea typeface="Times New Roman" panose="02020603050405020304" pitchFamily="18" charset="0"/>
-              <a:cs typeface="Arial" panose="020B0604020202020204" pitchFamily="34" charset="0"/>
-            </a:endParaRPr>
-          </a:p>
-        </p:txBody>
-      </p:sp>
-      <p:sp>
-        <p:nvSpPr>
           <p:cNvPr id="64" name="object 5">
             <a:extLst>
               <a:ext uri="{FF2B5EF4-FFF2-40B4-BE49-F238E27FC236}">
@@ -15204,62 +15036,6 @@
       </p:sp>
       <p:sp>
         <p:nvSpPr>
-          <p:cNvPr id="63" name="object 6">
-            <a:extLst>
-              <a:ext uri="{FF2B5EF4-FFF2-40B4-BE49-F238E27FC236}">
-                <a16:creationId xmlns:a16="http://schemas.microsoft.com/office/drawing/2014/main" id="{A92A90AF-5BC5-164C-BAE0-15271A672BC8}"/>
-              </a:ext>
-            </a:extLst>
-          </p:cNvPr>
-          <p:cNvSpPr txBox="1"/>
-          <p:nvPr/>
-        </p:nvSpPr>
-        <p:spPr>
-          <a:xfrm>
-            <a:off x="365811" y="239475"/>
-            <a:ext cx="328295" cy="187325"/>
-          </a:xfrm>
-          <a:prstGeom prst="rect">
-            <a:avLst/>
-          </a:prstGeom>
-        </p:spPr>
-        <p:txBody>
-          <a:bodyPr vert="horz" wrap="square" lIns="0" tIns="12700" rIns="0" bIns="0" rtlCol="0">
-            <a:spAutoFit/>
-          </a:bodyPr>
-          <a:lstStyle/>
-          <a:p>
-            <a:pPr marL="0" marR="0">
-              <a:spcBef>
-                <a:spcPts val="100"/>
-              </a:spcBef>
-              <a:spcAft>
-                <a:spcPts val="0"/>
-              </a:spcAft>
-            </a:pPr>
-            <a:r>
-              <a:rPr lang="en-US" sz="1100" kern="1200" spc="-40">
-                <a:solidFill>
-                  <a:srgbClr val="9B9B9B"/>
-                </a:solidFill>
-                <a:effectLst/>
-                <a:latin typeface="Arial" panose="020B0604020202020204" pitchFamily="34" charset="0"/>
-                <a:ea typeface="Times New Roman" panose="02020603050405020304" pitchFamily="18" charset="0"/>
-                <a:cs typeface="Arial" panose="020B0604020202020204" pitchFamily="34" charset="0"/>
-              </a:rPr>
-              <a:t>Title: AEGIS - Zero-Trust Identity for AI Agents</a:t>
-            </a:r>
-            <a:endParaRPr lang="en-US" sz="1100">
-              <a:effectLst/>
-              <a:latin typeface="Arial" panose="020B0604020202020204" pitchFamily="34" charset="0"/>
-              <a:ea typeface="Times New Roman" panose="02020603050405020304" pitchFamily="18" charset="0"/>
-              <a:cs typeface="Arial" panose="020B0604020202020204" pitchFamily="34" charset="0"/>
-            </a:endParaRPr>
-          </a:p>
-        </p:txBody>
-      </p:sp>
-      <p:sp>
-        <p:nvSpPr>
           <p:cNvPr id="64" name="object 5">
             <a:extLst>
               <a:ext uri="{FF2B5EF4-FFF2-40B4-BE49-F238E27FC236}">
@@ -15683,9 +15459,9 @@
           </a:stretch>
         </p:blipFill>
         <p:spPr>
-          <a:xfrm>
-            <a:off x="1086012" y="696595"/>
-            <a:ext cx="1490655" cy="2070100"/>
+          <a:xfrm rot="16200000">
+            <a:off x="929149" y="886241"/>
+            <a:ext cx="1405605" cy="1951989"/>
           </a:xfrm>
           <a:prstGeom prst="rect">
             <a:avLst/>
@@ -18312,62 +18088,6 @@
       </p:sp>
       <p:sp>
         <p:nvSpPr>
-          <p:cNvPr id="63" name="object 6">
-            <a:extLst>
-              <a:ext uri="{FF2B5EF4-FFF2-40B4-BE49-F238E27FC236}">
-                <a16:creationId xmlns:a16="http://schemas.microsoft.com/office/drawing/2014/main" id="{A92A90AF-5BC5-164C-BAE0-15271A672BC8}"/>
-              </a:ext>
-            </a:extLst>
-          </p:cNvPr>
-          <p:cNvSpPr txBox="1"/>
-          <p:nvPr/>
-        </p:nvSpPr>
-        <p:spPr>
-          <a:xfrm>
-            <a:off x="365811" y="239475"/>
-            <a:ext cx="328295" cy="187325"/>
-          </a:xfrm>
-          <a:prstGeom prst="rect">
-            <a:avLst/>
-          </a:prstGeom>
-        </p:spPr>
-        <p:txBody>
-          <a:bodyPr vert="horz" wrap="square" lIns="0" tIns="12700" rIns="0" bIns="0" rtlCol="0">
-            <a:spAutoFit/>
-          </a:bodyPr>
-          <a:lstStyle/>
-          <a:p>
-            <a:pPr marL="0" marR="0">
-              <a:spcBef>
-                <a:spcPts val="100"/>
-              </a:spcBef>
-              <a:spcAft>
-                <a:spcPts val="0"/>
-              </a:spcAft>
-            </a:pPr>
-            <a:r>
-              <a:rPr lang="en-US" sz="1100" kern="1200" spc="-40">
-                <a:solidFill>
-                  <a:srgbClr val="9B9B9B"/>
-                </a:solidFill>
-                <a:effectLst/>
-                <a:latin typeface="Arial" panose="020B0604020202020204" pitchFamily="34" charset="0"/>
-                <a:ea typeface="Times New Roman" panose="02020603050405020304" pitchFamily="18" charset="0"/>
-                <a:cs typeface="Arial" panose="020B0604020202020204" pitchFamily="34" charset="0"/>
-              </a:rPr>
-              <a:t>Title: AEGIS - Zero-Trust Identity for AI Agents</a:t>
-            </a:r>
-            <a:endParaRPr lang="en-US" sz="1100">
-              <a:effectLst/>
-              <a:latin typeface="Arial" panose="020B0604020202020204" pitchFamily="34" charset="0"/>
-              <a:ea typeface="Times New Roman" panose="02020603050405020304" pitchFamily="18" charset="0"/>
-              <a:cs typeface="Arial" panose="020B0604020202020204" pitchFamily="34" charset="0"/>
-            </a:endParaRPr>
-          </a:p>
-        </p:txBody>
-      </p:sp>
-      <p:sp>
-        <p:nvSpPr>
           <p:cNvPr id="64" name="object 5">
             <a:extLst>
               <a:ext uri="{FF2B5EF4-FFF2-40B4-BE49-F238E27FC236}">
@@ -18792,8 +18512,8 @@
         </p:blipFill>
         <p:spPr>
           <a:xfrm>
-            <a:off x="340868" y="696595"/>
-            <a:ext cx="2980944" cy="2070100"/>
+            <a:off x="630614" y="1083640"/>
+            <a:ext cx="2388751" cy="1658855"/>
           </a:xfrm>
           <a:prstGeom prst="rect">
             <a:avLst/>
@@ -18818,6 +18538,78 @@
           <a:xfrm>
             <a:off x="7235190" y="4361584"/>
             <a:ext cx="3187700" cy="1217121"/>
+          </a:xfrm>
+          <a:prstGeom prst="rect">
+            <a:avLst/>
+          </a:prstGeom>
+        </p:spPr>
+      </p:pic>
+      <p:pic>
+        <p:nvPicPr>
+          <p:cNvPr id="73" name="Picture 72" descr="dash_live_attack.png"/>
+          <p:cNvPicPr>
+            <a:picLocks noChangeAspect="1"/>
+          </p:cNvPicPr>
+          <p:nvPr/>
+        </p:nvPicPr>
+        <p:blipFill>
+          <a:blip r:embed="rId5"/>
+          <a:stretch>
+            <a:fillRect/>
+          </a:stretch>
+        </p:blipFill>
+        <p:spPr>
+          <a:xfrm>
+            <a:off x="3729990" y="835104"/>
+            <a:ext cx="3187700" cy="1793081"/>
+          </a:xfrm>
+          <a:prstGeom prst="rect">
+            <a:avLst/>
+          </a:prstGeom>
+        </p:spPr>
+      </p:pic>
+      <p:pic>
+        <p:nvPicPr>
+          <p:cNvPr id="74" name="Picture 73" descr="dash_topology.png"/>
+          <p:cNvPicPr>
+            <a:picLocks noChangeAspect="1"/>
+          </p:cNvPicPr>
+          <p:nvPr/>
+        </p:nvPicPr>
+        <p:blipFill>
+          <a:blip r:embed="rId6"/>
+          <a:stretch>
+            <a:fillRect/>
+          </a:stretch>
+        </p:blipFill>
+        <p:spPr>
+          <a:xfrm>
+            <a:off x="7235190" y="835104"/>
+            <a:ext cx="3187700" cy="1793081"/>
+          </a:xfrm>
+          <a:prstGeom prst="rect">
+            <a:avLst/>
+          </a:prstGeom>
+        </p:spPr>
+      </p:pic>
+      <p:pic>
+        <p:nvPicPr>
+          <p:cNvPr id="75" name="Picture 74" descr="dash_incident_inspector.png"/>
+          <p:cNvPicPr>
+            <a:picLocks noChangeAspect="1"/>
+          </p:cNvPicPr>
+          <p:nvPr/>
+        </p:nvPicPr>
+        <p:blipFill>
+          <a:blip r:embed="rId7"/>
+          <a:stretch>
+            <a:fillRect/>
+          </a:stretch>
+        </p:blipFill>
+        <p:spPr>
+          <a:xfrm>
+            <a:off x="237490" y="4073604"/>
+            <a:ext cx="3187700" cy="1793081"/>
           </a:xfrm>
           <a:prstGeom prst="rect">
             <a:avLst/>
@@ -21905,6 +21697,30 @@
           <a:xfrm>
             <a:off x="7235190" y="4361584"/>
             <a:ext cx="3187700" cy="1217121"/>
+          </a:xfrm>
+          <a:prstGeom prst="rect">
+            <a:avLst/>
+          </a:prstGeom>
+        </p:spPr>
+      </p:pic>
+      <p:pic>
+        <p:nvPicPr>
+          <p:cNvPr id="72" name="Picture 71" descr="open5gs_terminal.png"/>
+          <p:cNvPicPr>
+            <a:picLocks noChangeAspect="1"/>
+          </p:cNvPicPr>
+          <p:nvPr/>
+        </p:nvPicPr>
+        <p:blipFill>
+          <a:blip r:embed="rId4"/>
+          <a:stretch>
+            <a:fillRect/>
+          </a:stretch>
+        </p:blipFill>
+        <p:spPr>
+          <a:xfrm>
+            <a:off x="237490" y="934720"/>
+            <a:ext cx="3187700" cy="1593850"/>
           </a:xfrm>
           <a:prstGeom prst="rect">
             <a:avLst/>
@@ -28835,15 +28651,6 @@
 </file>
 
 <file path=customXml/item1.xml><?xml version="1.0" encoding="utf-8"?>
-<?mso-contentType ?>
-<FormTemplates xmlns="http://schemas.microsoft.com/sharepoint/v3/contenttype/forms">
-  <Display>DocumentLibraryForm</Display>
-  <Edit>DocumentLibraryForm</Edit>
-  <New>DocumentLibraryForm</New>
-</FormTemplates>
-</file>
-
-<file path=customXml/item2.xml><?xml version="1.0" encoding="utf-8"?>
 <ct:contentTypeSchema xmlns:ct="http://schemas.microsoft.com/office/2006/metadata/contentType" xmlns:ma="http://schemas.microsoft.com/office/2006/metadata/properties/metaAttributes" ct:_="" ma:_="" ma:contentTypeName="Document" ma:contentTypeID="0x010100942D7E2E766E274BA85FFEF303FE3B84" ma:contentTypeVersion="11" ma:contentTypeDescription="Create a new document." ma:contentTypeScope="" ma:versionID="161f57f8e4da8c53066cecce20e1cf28">
   <xsd:schema xmlns:xsd="http://www.w3.org/2001/XMLSchema" xmlns:xs="http://www.w3.org/2001/XMLSchema" xmlns:p="http://schemas.microsoft.com/office/2006/metadata/properties" xmlns:ns2="df1bf422-076b-4923-a343-86f92e681c13" xmlns:ns3="17320c4f-b4d7-4a2f-a568-c234bef09358" targetNamespace="http://schemas.microsoft.com/office/2006/metadata/properties" ma:root="true" ma:fieldsID="3f75c0bee81b84287f3a5e0ecbeaea68" ns2:_="" ns3:_="">
     <xsd:import namespace="df1bf422-076b-4923-a343-86f92e681c13"/>
@@ -29038,6 +28845,15 @@
 </ct:contentTypeSchema>
 </file>
 
+<file path=customXml/item2.xml><?xml version="1.0" encoding="utf-8"?>
+<?mso-contentType ?>
+<FormTemplates xmlns="http://schemas.microsoft.com/sharepoint/v3/contenttype/forms">
+  <Display>DocumentLibraryForm</Display>
+  <Edit>DocumentLibraryForm</Edit>
+  <New>DocumentLibraryForm</New>
+</FormTemplates>
+</file>
+
 <file path=customXml/item3.xml><?xml version="1.0" encoding="utf-8"?>
 <p:properties xmlns:p="http://schemas.microsoft.com/office/2006/metadata/properties" xmlns:xsi="http://www.w3.org/2001/XMLSchema-instance" xmlns:pc="http://schemas.microsoft.com/office/infopath/2007/PartnerControls">
   <documentManagement>
@@ -29050,14 +28866,6 @@
 </file>
 
 <file path=customXml/itemProps1.xml><?xml version="1.0" encoding="utf-8"?>
-<ds:datastoreItem xmlns:ds="http://schemas.openxmlformats.org/officeDocument/2006/customXml" ds:itemID="{2AA5AF62-29D7-49C4-96C6-35C102D42BEC}">
-  <ds:schemaRefs>
-    <ds:schemaRef ds:uri="http://schemas.microsoft.com/sharepoint/v3/contenttype/forms"/>
-  </ds:schemaRefs>
-</ds:datastoreItem>
-</file>
-
-<file path=customXml/itemProps2.xml><?xml version="1.0" encoding="utf-8"?>
 <ds:datastoreItem xmlns:ds="http://schemas.openxmlformats.org/officeDocument/2006/customXml" ds:itemID="{AFE32100-327A-46D5-A299-81E97F5FBF53}">
   <ds:schemaRefs>
     <ds:schemaRef ds:uri="http://schemas.microsoft.com/office/2006/metadata/contentType"/>
@@ -29072,6 +28880,14 @@
     <ds:schemaRef ds:uri="http://purl.org/dc/elements/1.1/"/>
     <ds:schemaRef ds:uri="http://purl.org/dc/terms/"/>
     <ds:schemaRef ds:uri="http://schemas.microsoft.com/internal/obd"/>
+  </ds:schemaRefs>
+</ds:datastoreItem>
+</file>
+
+<file path=customXml/itemProps2.xml><?xml version="1.0" encoding="utf-8"?>
+<ds:datastoreItem xmlns:ds="http://schemas.openxmlformats.org/officeDocument/2006/customXml" ds:itemID="{2AA5AF62-29D7-49C4-96C6-35C102D42BEC}">
+  <ds:schemaRefs>
+    <ds:schemaRef ds:uri="http://schemas.microsoft.com/sharepoint/v3/contenttype/forms"/>
   </ds:schemaRefs>
 </ds:datastoreItem>
 </file>

</xml_diff>